<commit_message>
feat(presentation): migra defensa a Beamer y paleta clara
</commit_message>
<xml_diff>
--- a/documentacion/presentacion/defensa_fraude.pptx
+++ b/documentacion/presentacion/defensa_fraude.pptx
@@ -3116,7 +3116,7 @@
             <a:avLst/>
           </a:prstGeom>
           <a:solidFill>
-            <a:srgbClr val="121B2A"/>
+            <a:srgbClr val="FFFFFF"/>
           </a:solidFill>
           <a:ln>
             <a:noFill/>
@@ -3174,7 +3174,7 @@
             <a:r>
               <a:rPr sz="1100" b="1">
                 <a:solidFill>
-                  <a:srgbClr val="4AB8A7"/>
+                  <a:srgbClr val="2E6F9E"/>
                 </a:solidFill>
                 <a:latin typeface="Arial"/>
               </a:rPr>
@@ -3213,7 +3213,7 @@
             <a:r>
               <a:rPr sz="3800" b="1">
                 <a:solidFill>
-                  <a:srgbClr val="EBF0F6"/>
+                  <a:srgbClr val="263238"/>
                 </a:solidFill>
                 <a:latin typeface="Arial"/>
               </a:rPr>
@@ -3253,7 +3253,7 @@
             <a:r>
               <a:rPr sz="2000" b="0">
                 <a:solidFill>
-                  <a:srgbClr val="ABB9C7"/>
+                  <a:srgbClr val="64748B"/>
                 </a:solidFill>
                 <a:latin typeface="Arial"/>
               </a:rPr>
@@ -3292,7 +3292,7 @@
             <a:r>
               <a:rPr sz="1700" b="1">
                 <a:solidFill>
-                  <a:srgbClr val="E8874B"/>
+                  <a:srgbClr val="A8B4C0"/>
                 </a:solidFill>
                 <a:latin typeface="Arial"/>
               </a:rPr>
@@ -3331,7 +3331,7 @@
             <a:r>
               <a:rPr sz="1300" b="0">
                 <a:solidFill>
-                  <a:srgbClr val="ABB9C7"/>
+                  <a:srgbClr val="64748B"/>
                 </a:solidFill>
                 <a:latin typeface="Arial"/>
               </a:rPr>
@@ -3355,7 +3355,7 @@
             <a:avLst/>
           </a:prstGeom>
           <a:solidFill>
-            <a:srgbClr val="1C2A3D"/>
+            <a:srgbClr val="F1F5F9"/>
           </a:solidFill>
           <a:ln>
             <a:noFill/>
@@ -3413,7 +3413,7 @@
             <a:r>
               <a:rPr sz="2500" b="1">
                 <a:solidFill>
-                  <a:srgbClr val="4AB8A7"/>
+                  <a:srgbClr val="2E6F9E"/>
                 </a:solidFill>
                 <a:latin typeface="Arial"/>
               </a:rPr>
@@ -3452,7 +3452,7 @@
             <a:r>
               <a:rPr sz="1200" b="1">
                 <a:solidFill>
-                  <a:srgbClr val="EBF0F6"/>
+                  <a:srgbClr val="263238"/>
                 </a:solidFill>
                 <a:latin typeface="Arial"/>
               </a:rPr>
@@ -3476,7 +3476,7 @@
             <a:avLst/>
           </a:prstGeom>
           <a:solidFill>
-            <a:srgbClr val="1C2A3D"/>
+            <a:srgbClr val="F1F5F9"/>
           </a:solidFill>
           <a:ln>
             <a:noFill/>
@@ -3534,7 +3534,7 @@
             <a:r>
               <a:rPr sz="2500" b="1">
                 <a:solidFill>
-                  <a:srgbClr val="E8874B"/>
+                  <a:srgbClr val="A8B4C0"/>
                 </a:solidFill>
                 <a:latin typeface="Arial"/>
               </a:rPr>
@@ -3573,7 +3573,7 @@
             <a:r>
               <a:rPr sz="1200" b="1">
                 <a:solidFill>
-                  <a:srgbClr val="EBF0F6"/>
+                  <a:srgbClr val="263238"/>
                 </a:solidFill>
                 <a:latin typeface="Arial"/>
               </a:rPr>
@@ -3612,7 +3612,7 @@
             <a:r>
               <a:rPr sz="1200" b="0">
                 <a:solidFill>
-                  <a:srgbClr val="ABB9C7"/>
+                  <a:srgbClr val="64748B"/>
                 </a:solidFill>
                 <a:latin typeface="Arial"/>
               </a:rPr>
@@ -3654,7 +3654,7 @@
             <a:avLst/>
           </a:prstGeom>
           <a:solidFill>
-            <a:srgbClr val="121B2A"/>
+            <a:srgbClr val="FFFFFF"/>
           </a:solidFill>
           <a:ln>
             <a:noFill/>
@@ -3712,7 +3712,7 @@
             <a:r>
               <a:rPr sz="1000" b="1">
                 <a:solidFill>
-                  <a:srgbClr val="4AB8A7"/>
+                  <a:srgbClr val="2E6F9E"/>
                 </a:solidFill>
                 <a:latin typeface="Arial"/>
               </a:rPr>
@@ -3751,7 +3751,7 @@
             <a:r>
               <a:rPr sz="2600" b="1">
                 <a:solidFill>
-                  <a:srgbClr val="EBF0F6"/>
+                  <a:srgbClr val="263238"/>
                 </a:solidFill>
                 <a:latin typeface="Arial"/>
               </a:rPr>
@@ -3775,7 +3775,7 @@
             <a:avLst/>
           </a:prstGeom>
           <a:solidFill>
-            <a:srgbClr val="1C2A3D"/>
+            <a:srgbClr val="F1F5F9"/>
           </a:solidFill>
           <a:ln>
             <a:noFill/>
@@ -3833,7 +3833,7 @@
             <a:r>
               <a:rPr sz="900" b="0">
                 <a:solidFill>
-                  <a:srgbClr val="ABB9C7"/>
+                  <a:srgbClr val="64748B"/>
                 </a:solidFill>
                 <a:latin typeface="Arial"/>
               </a:rPr>
@@ -3872,7 +3872,7 @@
             <a:r>
               <a:rPr sz="1000" b="0">
                 <a:solidFill>
-                  <a:srgbClr val="ABB9C7"/>
+                  <a:srgbClr val="64748B"/>
                 </a:solidFill>
                 <a:latin typeface="Arial"/>
               </a:rPr>
@@ -3920,7 +3920,7 @@
             <a:avLst/>
           </a:prstGeom>
           <a:solidFill>
-            <a:srgbClr val="1C2A3D"/>
+            <a:srgbClr val="F1F5F9"/>
           </a:solidFill>
           <a:ln>
             <a:noFill/>
@@ -3978,7 +3978,7 @@
             <a:r>
               <a:rPr sz="2500" b="1">
                 <a:solidFill>
-                  <a:srgbClr val="4AB8A7"/>
+                  <a:srgbClr val="2E6F9E"/>
                 </a:solidFill>
                 <a:latin typeface="Arial"/>
               </a:rPr>
@@ -4017,7 +4017,7 @@
             <a:r>
               <a:rPr sz="1200" b="1">
                 <a:solidFill>
-                  <a:srgbClr val="EBF0F6"/>
+                  <a:srgbClr val="263238"/>
                 </a:solidFill>
                 <a:latin typeface="Arial"/>
               </a:rPr>
@@ -4041,7 +4041,7 @@
             <a:avLst/>
           </a:prstGeom>
           <a:solidFill>
-            <a:srgbClr val="1C2A3D"/>
+            <a:srgbClr val="F1F5F9"/>
           </a:solidFill>
           <a:ln>
             <a:noFill/>
@@ -4099,7 +4099,7 @@
             <a:r>
               <a:rPr sz="2500" b="1">
                 <a:solidFill>
-                  <a:srgbClr val="E8874B"/>
+                  <a:srgbClr val="A8B4C0"/>
                 </a:solidFill>
                 <a:latin typeface="Arial"/>
               </a:rPr>
@@ -4138,7 +4138,7 @@
             <a:r>
               <a:rPr sz="1200" b="1">
                 <a:solidFill>
-                  <a:srgbClr val="EBF0F6"/>
+                  <a:srgbClr val="263238"/>
                 </a:solidFill>
                 <a:latin typeface="Arial"/>
               </a:rPr>
@@ -4162,7 +4162,7 @@
             <a:avLst/>
           </a:prstGeom>
           <a:solidFill>
-            <a:srgbClr val="1C2A3D"/>
+            <a:srgbClr val="F1F5F9"/>
           </a:solidFill>
           <a:ln>
             <a:noFill/>
@@ -4220,7 +4220,7 @@
             <a:r>
               <a:rPr sz="2500" b="1">
                 <a:solidFill>
-                  <a:srgbClr val="E8874B"/>
+                  <a:srgbClr val="A8B4C0"/>
                 </a:solidFill>
                 <a:latin typeface="Arial"/>
               </a:rPr>
@@ -4259,7 +4259,7 @@
             <a:r>
               <a:rPr sz="1200" b="1">
                 <a:solidFill>
-                  <a:srgbClr val="EBF0F6"/>
+                  <a:srgbClr val="263238"/>
                 </a:solidFill>
                 <a:latin typeface="Arial"/>
               </a:rPr>
@@ -4283,7 +4283,7 @@
             <a:avLst/>
           </a:prstGeom>
           <a:solidFill>
-            <a:srgbClr val="1C2A3D"/>
+            <a:srgbClr val="F1F5F9"/>
           </a:solidFill>
           <a:ln>
             <a:noFill/>
@@ -4341,7 +4341,7 @@
             <a:r>
               <a:rPr sz="2500" b="1">
                 <a:solidFill>
-                  <a:srgbClr val="4AB8A7"/>
+                  <a:srgbClr val="2E6F9E"/>
                 </a:solidFill>
                 <a:latin typeface="Arial"/>
               </a:rPr>
@@ -4380,7 +4380,7 @@
             <a:r>
               <a:rPr sz="1200" b="1">
                 <a:solidFill>
-                  <a:srgbClr val="EBF0F6"/>
+                  <a:srgbClr val="263238"/>
                 </a:solidFill>
                 <a:latin typeface="Arial"/>
               </a:rPr>
@@ -4419,7 +4419,7 @@
             <a:r>
               <a:rPr sz="1200" b="0">
                 <a:solidFill>
-                  <a:srgbClr val="ABB9C7"/>
+                  <a:srgbClr val="64748B"/>
                 </a:solidFill>
                 <a:latin typeface="Arial"/>
               </a:rPr>
@@ -4461,7 +4461,7 @@
             <a:avLst/>
           </a:prstGeom>
           <a:solidFill>
-            <a:srgbClr val="121B2A"/>
+            <a:srgbClr val="FFFFFF"/>
           </a:solidFill>
           <a:ln>
             <a:noFill/>
@@ -4519,7 +4519,7 @@
             <a:r>
               <a:rPr sz="1000" b="1">
                 <a:solidFill>
-                  <a:srgbClr val="4AB8A7"/>
+                  <a:srgbClr val="2E6F9E"/>
                 </a:solidFill>
                 <a:latin typeface="Arial"/>
               </a:rPr>
@@ -4558,7 +4558,7 @@
             <a:r>
               <a:rPr sz="2600" b="1">
                 <a:solidFill>
-                  <a:srgbClr val="EBF0F6"/>
+                  <a:srgbClr val="263238"/>
                 </a:solidFill>
                 <a:latin typeface="Arial"/>
               </a:rPr>
@@ -4582,7 +4582,7 @@
             <a:avLst/>
           </a:prstGeom>
           <a:solidFill>
-            <a:srgbClr val="1C2A3D"/>
+            <a:srgbClr val="F1F5F9"/>
           </a:solidFill>
           <a:ln>
             <a:noFill/>
@@ -4640,7 +4640,7 @@
             <a:r>
               <a:rPr sz="900" b="0">
                 <a:solidFill>
-                  <a:srgbClr val="ABB9C7"/>
+                  <a:srgbClr val="64748B"/>
                 </a:solidFill>
                 <a:latin typeface="Arial"/>
               </a:rPr>
@@ -4679,7 +4679,7 @@
             <a:r>
               <a:rPr sz="1000" b="0">
                 <a:solidFill>
-                  <a:srgbClr val="ABB9C7"/>
+                  <a:srgbClr val="64748B"/>
                 </a:solidFill>
                 <a:latin typeface="Arial"/>
               </a:rPr>
@@ -4703,7 +4703,7 @@
             <a:avLst/>
           </a:prstGeom>
           <a:solidFill>
-            <a:srgbClr val="1C2A3D"/>
+            <a:srgbClr val="F1F5F9"/>
           </a:solidFill>
           <a:ln>
             <a:noFill/>
@@ -4761,7 +4761,7 @@
             <a:r>
               <a:rPr sz="2500" b="1">
                 <a:solidFill>
-                  <a:srgbClr val="E8874B"/>
+                  <a:srgbClr val="A8B4C0"/>
                 </a:solidFill>
                 <a:latin typeface="Arial"/>
               </a:rPr>
@@ -4800,7 +4800,7 @@
             <a:r>
               <a:rPr sz="1200" b="1">
                 <a:solidFill>
-                  <a:srgbClr val="EBF0F6"/>
+                  <a:srgbClr val="263238"/>
                 </a:solidFill>
                 <a:latin typeface="Arial"/>
               </a:rPr>
@@ -4839,7 +4839,7 @@
             <a:r>
               <a:rPr sz="1000" b="0">
                 <a:solidFill>
-                  <a:srgbClr val="ABB9C7"/>
+                  <a:srgbClr val="64748B"/>
                 </a:solidFill>
                 <a:latin typeface="Arial"/>
               </a:rPr>
@@ -4863,7 +4863,7 @@
             <a:avLst/>
           </a:prstGeom>
           <a:solidFill>
-            <a:srgbClr val="1C2A3D"/>
+            <a:srgbClr val="F1F5F9"/>
           </a:solidFill>
           <a:ln>
             <a:noFill/>
@@ -4921,7 +4921,7 @@
             <a:r>
               <a:rPr sz="2500" b="1">
                 <a:solidFill>
-                  <a:srgbClr val="4AB8A7"/>
+                  <a:srgbClr val="2E6F9E"/>
                 </a:solidFill>
                 <a:latin typeface="Arial"/>
               </a:rPr>
@@ -4960,7 +4960,7 @@
             <a:r>
               <a:rPr sz="1200" b="1">
                 <a:solidFill>
-                  <a:srgbClr val="EBF0F6"/>
+                  <a:srgbClr val="263238"/>
                 </a:solidFill>
                 <a:latin typeface="Arial"/>
               </a:rPr>
@@ -4999,7 +4999,7 @@
             <a:r>
               <a:rPr sz="1000" b="0">
                 <a:solidFill>
-                  <a:srgbClr val="ABB9C7"/>
+                  <a:srgbClr val="64748B"/>
                 </a:solidFill>
                 <a:latin typeface="Arial"/>
               </a:rPr>
@@ -5023,7 +5023,7 @@
             <a:avLst/>
           </a:prstGeom>
           <a:solidFill>
-            <a:srgbClr val="1C2A3D"/>
+            <a:srgbClr val="F1F5F9"/>
           </a:solidFill>
           <a:ln>
             <a:noFill/>
@@ -5081,7 +5081,7 @@
             <a:r>
               <a:rPr sz="2500" b="1">
                 <a:solidFill>
-                  <a:srgbClr val="E8874B"/>
+                  <a:srgbClr val="A8B4C0"/>
                 </a:solidFill>
                 <a:latin typeface="Arial"/>
               </a:rPr>
@@ -5120,7 +5120,7 @@
             <a:r>
               <a:rPr sz="1200" b="1">
                 <a:solidFill>
-                  <a:srgbClr val="EBF0F6"/>
+                  <a:srgbClr val="263238"/>
                 </a:solidFill>
                 <a:latin typeface="Arial"/>
               </a:rPr>
@@ -5159,7 +5159,7 @@
             <a:r>
               <a:rPr sz="1000" b="0">
                 <a:solidFill>
-                  <a:srgbClr val="ABB9C7"/>
+                  <a:srgbClr val="64748B"/>
                 </a:solidFill>
                 <a:latin typeface="Arial"/>
               </a:rPr>
@@ -5183,7 +5183,7 @@
             <a:avLst/>
           </a:prstGeom>
           <a:solidFill>
-            <a:srgbClr val="E8874B"/>
+            <a:srgbClr val="A8B4C0"/>
           </a:solidFill>
           <a:ln>
             <a:noFill/>
@@ -5241,7 +5241,7 @@
             <a:r>
               <a:rPr sz="1400" b="0">
                 <a:solidFill>
-                  <a:srgbClr val="EBF0F6"/>
+                  <a:srgbClr val="263238"/>
                 </a:solidFill>
                 <a:latin typeface="Arial"/>
               </a:rPr>
@@ -5265,7 +5265,7 @@
             <a:avLst/>
           </a:prstGeom>
           <a:solidFill>
-            <a:srgbClr val="4AB8A7"/>
+            <a:srgbClr val="2E6F9E"/>
           </a:solidFill>
           <a:ln>
             <a:noFill/>
@@ -5323,7 +5323,7 @@
             <a:r>
               <a:rPr sz="1400" b="0">
                 <a:solidFill>
-                  <a:srgbClr val="EBF0F6"/>
+                  <a:srgbClr val="263238"/>
                 </a:solidFill>
                 <a:latin typeface="Arial"/>
               </a:rPr>
@@ -5347,7 +5347,7 @@
             <a:avLst/>
           </a:prstGeom>
           <a:solidFill>
-            <a:srgbClr val="4AB8A7"/>
+            <a:srgbClr val="2E6F9E"/>
           </a:solidFill>
           <a:ln>
             <a:noFill/>
@@ -5405,7 +5405,7 @@
             <a:r>
               <a:rPr sz="1400" b="0">
                 <a:solidFill>
-                  <a:srgbClr val="EBF0F6"/>
+                  <a:srgbClr val="263238"/>
                 </a:solidFill>
                 <a:latin typeface="Arial"/>
               </a:rPr>
@@ -5447,7 +5447,7 @@
             <a:avLst/>
           </a:prstGeom>
           <a:solidFill>
-            <a:srgbClr val="121B2A"/>
+            <a:srgbClr val="FFFFFF"/>
           </a:solidFill>
           <a:ln>
             <a:noFill/>
@@ -5505,7 +5505,7 @@
             <a:r>
               <a:rPr sz="1000" b="1">
                 <a:solidFill>
-                  <a:srgbClr val="4AB8A7"/>
+                  <a:srgbClr val="2E6F9E"/>
                 </a:solidFill>
                 <a:latin typeface="Arial"/>
               </a:rPr>
@@ -5544,7 +5544,7 @@
             <a:r>
               <a:rPr sz="2600" b="1">
                 <a:solidFill>
-                  <a:srgbClr val="EBF0F6"/>
+                  <a:srgbClr val="263238"/>
                 </a:solidFill>
                 <a:latin typeface="Arial"/>
               </a:rPr>
@@ -5568,7 +5568,7 @@
             <a:avLst/>
           </a:prstGeom>
           <a:solidFill>
-            <a:srgbClr val="1C2A3D"/>
+            <a:srgbClr val="F1F5F9"/>
           </a:solidFill>
           <a:ln>
             <a:noFill/>
@@ -5626,7 +5626,7 @@
             <a:r>
               <a:rPr sz="900" b="0">
                 <a:solidFill>
-                  <a:srgbClr val="ABB9C7"/>
+                  <a:srgbClr val="64748B"/>
                 </a:solidFill>
                 <a:latin typeface="Arial"/>
               </a:rPr>
@@ -5665,7 +5665,7 @@
             <a:r>
               <a:rPr sz="1000" b="0">
                 <a:solidFill>
-                  <a:srgbClr val="ABB9C7"/>
+                  <a:srgbClr val="64748B"/>
                 </a:solidFill>
                 <a:latin typeface="Arial"/>
               </a:rPr>
@@ -5689,7 +5689,7 @@
             <a:avLst/>
           </a:prstGeom>
           <a:solidFill>
-            <a:srgbClr val="1C2A3D"/>
+            <a:srgbClr val="F1F5F9"/>
           </a:solidFill>
           <a:ln>
             <a:noFill/>
@@ -5747,7 +5747,7 @@
             <a:r>
               <a:rPr sz="2500" b="1">
                 <a:solidFill>
-                  <a:srgbClr val="4AB8A7"/>
+                  <a:srgbClr val="2E6F9E"/>
                 </a:solidFill>
                 <a:latin typeface="Arial"/>
               </a:rPr>
@@ -5786,7 +5786,7 @@
             <a:r>
               <a:rPr sz="1200" b="1">
                 <a:solidFill>
-                  <a:srgbClr val="EBF0F6"/>
+                  <a:srgbClr val="263238"/>
                 </a:solidFill>
                 <a:latin typeface="Arial"/>
               </a:rPr>
@@ -5825,7 +5825,7 @@
             <a:r>
               <a:rPr sz="1000" b="0">
                 <a:solidFill>
-                  <a:srgbClr val="ABB9C7"/>
+                  <a:srgbClr val="64748B"/>
                 </a:solidFill>
                 <a:latin typeface="Arial"/>
               </a:rPr>
@@ -5849,7 +5849,7 @@
             <a:avLst/>
           </a:prstGeom>
           <a:solidFill>
-            <a:srgbClr val="E8874B"/>
+            <a:srgbClr val="A8B4C0"/>
           </a:solidFill>
           <a:ln>
             <a:noFill/>
@@ -5907,7 +5907,7 @@
             <a:r>
               <a:rPr sz="1400" b="0">
                 <a:solidFill>
-                  <a:srgbClr val="EBF0F6"/>
+                  <a:srgbClr val="263238"/>
                 </a:solidFill>
                 <a:latin typeface="Arial"/>
               </a:rPr>
@@ -5931,7 +5931,7 @@
             <a:avLst/>
           </a:prstGeom>
           <a:solidFill>
-            <a:srgbClr val="4AB8A7"/>
+            <a:srgbClr val="2E6F9E"/>
           </a:solidFill>
           <a:ln>
             <a:noFill/>
@@ -5989,7 +5989,7 @@
             <a:r>
               <a:rPr sz="1400" b="0">
                 <a:solidFill>
-                  <a:srgbClr val="EBF0F6"/>
+                  <a:srgbClr val="263238"/>
                 </a:solidFill>
                 <a:latin typeface="Arial"/>
               </a:rPr>
@@ -6013,7 +6013,7 @@
             <a:avLst/>
           </a:prstGeom>
           <a:solidFill>
-            <a:srgbClr val="4AB8A7"/>
+            <a:srgbClr val="2E6F9E"/>
           </a:solidFill>
           <a:ln>
             <a:noFill/>
@@ -6071,7 +6071,7 @@
             <a:r>
               <a:rPr sz="1400" b="0">
                 <a:solidFill>
-                  <a:srgbClr val="EBF0F6"/>
+                  <a:srgbClr val="263238"/>
                 </a:solidFill>
                 <a:latin typeface="Arial"/>
               </a:rPr>
@@ -6095,7 +6095,7 @@
             <a:avLst/>
           </a:prstGeom>
           <a:solidFill>
-            <a:srgbClr val="4AB8A7"/>
+            <a:srgbClr val="2E6F9E"/>
           </a:solidFill>
           <a:ln>
             <a:noFill/>
@@ -6153,7 +6153,7 @@
             <a:r>
               <a:rPr sz="1400" b="0">
                 <a:solidFill>
-                  <a:srgbClr val="EBF0F6"/>
+                  <a:srgbClr val="263238"/>
                 </a:solidFill>
                 <a:latin typeface="Arial"/>
               </a:rPr>
@@ -6177,7 +6177,7 @@
             <a:avLst/>
           </a:prstGeom>
           <a:solidFill>
-            <a:srgbClr val="4AB8A7"/>
+            <a:srgbClr val="2E6F9E"/>
           </a:solidFill>
           <a:ln>
             <a:noFill/>
@@ -6235,7 +6235,7 @@
             <a:r>
               <a:rPr sz="1400" b="0">
                 <a:solidFill>
-                  <a:srgbClr val="EBF0F6"/>
+                  <a:srgbClr val="263238"/>
                 </a:solidFill>
                 <a:latin typeface="Arial"/>
               </a:rPr>
@@ -6274,7 +6274,7 @@
             <a:r>
               <a:rPr sz="1300" b="0">
                 <a:solidFill>
-                  <a:srgbClr val="ABB9C7"/>
+                  <a:srgbClr val="64748B"/>
                 </a:solidFill>
                 <a:latin typeface="Arial"/>
               </a:rPr>
@@ -6316,7 +6316,7 @@
             <a:avLst/>
           </a:prstGeom>
           <a:solidFill>
-            <a:srgbClr val="121B2A"/>
+            <a:srgbClr val="FFFFFF"/>
           </a:solidFill>
           <a:ln>
             <a:noFill/>
@@ -6374,7 +6374,7 @@
             <a:r>
               <a:rPr sz="1000" b="1">
                 <a:solidFill>
-                  <a:srgbClr val="4AB8A7"/>
+                  <a:srgbClr val="2E6F9E"/>
                 </a:solidFill>
                 <a:latin typeface="Arial"/>
               </a:rPr>
@@ -6413,7 +6413,7 @@
             <a:r>
               <a:rPr sz="2600" b="1">
                 <a:solidFill>
-                  <a:srgbClr val="EBF0F6"/>
+                  <a:srgbClr val="263238"/>
                 </a:solidFill>
                 <a:latin typeface="Arial"/>
               </a:rPr>
@@ -6452,7 +6452,7 @@
             <a:r>
               <a:rPr sz="1200" b="0">
                 <a:solidFill>
-                  <a:srgbClr val="ABB9C7"/>
+                  <a:srgbClr val="64748B"/>
                 </a:solidFill>
                 <a:latin typeface="Arial"/>
               </a:rPr>
@@ -6476,7 +6476,7 @@
             <a:avLst/>
           </a:prstGeom>
           <a:solidFill>
-            <a:srgbClr val="1C2A3D"/>
+            <a:srgbClr val="F1F5F9"/>
           </a:solidFill>
           <a:ln>
             <a:noFill/>
@@ -6534,7 +6534,7 @@
             <a:r>
               <a:rPr sz="900" b="0">
                 <a:solidFill>
-                  <a:srgbClr val="ABB9C7"/>
+                  <a:srgbClr val="64748B"/>
                 </a:solidFill>
                 <a:latin typeface="Arial"/>
               </a:rPr>
@@ -6573,7 +6573,7 @@
             <a:r>
               <a:rPr sz="1000" b="0">
                 <a:solidFill>
-                  <a:srgbClr val="ABB9C7"/>
+                  <a:srgbClr val="64748B"/>
                 </a:solidFill>
                 <a:latin typeface="Arial"/>
               </a:rPr>
@@ -6617,7 +6617,7 @@
                       <a:r>
                         <a:rPr sz="1000" b="1">
                           <a:solidFill>
-                            <a:srgbClr val="EBF0F6"/>
+                            <a:srgbClr val="263238"/>
                           </a:solidFill>
                           <a:latin typeface="Arial"/>
                         </a:rPr>
@@ -6627,7 +6627,7 @@
                   </a:txBody>
                   <a:tcPr marL="54864" marR="45720" marT="22860" marB="22860">
                     <a:solidFill>
-                      <a:srgbClr val="2A3E52"/>
+                      <a:srgbClr val="DCE8F1"/>
                     </a:solidFill>
                   </a:tcPr>
                 </a:tc>
@@ -6640,7 +6640,7 @@
                       <a:r>
                         <a:rPr sz="1000" b="1">
                           <a:solidFill>
-                            <a:srgbClr val="EBF0F6"/>
+                            <a:srgbClr val="263238"/>
                           </a:solidFill>
                           <a:latin typeface="Arial"/>
                         </a:rPr>
@@ -6650,7 +6650,7 @@
                   </a:txBody>
                   <a:tcPr marL="54864" marR="45720" marT="22860" marB="22860">
                     <a:solidFill>
-                      <a:srgbClr val="2A3E52"/>
+                      <a:srgbClr val="DCE8F1"/>
                     </a:solidFill>
                   </a:tcPr>
                 </a:tc>
@@ -6663,7 +6663,7 @@
                       <a:r>
                         <a:rPr sz="1000" b="1">
                           <a:solidFill>
-                            <a:srgbClr val="EBF0F6"/>
+                            <a:srgbClr val="263238"/>
                           </a:solidFill>
                           <a:latin typeface="Arial"/>
                         </a:rPr>
@@ -6673,7 +6673,7 @@
                   </a:txBody>
                   <a:tcPr marL="54864" marR="45720" marT="22860" marB="22860">
                     <a:solidFill>
-                      <a:srgbClr val="2A3E52"/>
+                      <a:srgbClr val="DCE8F1"/>
                     </a:solidFill>
                   </a:tcPr>
                 </a:tc>
@@ -6686,7 +6686,7 @@
                       <a:r>
                         <a:rPr sz="1000" b="1">
                           <a:solidFill>
-                            <a:srgbClr val="EBF0F6"/>
+                            <a:srgbClr val="263238"/>
                           </a:solidFill>
                           <a:latin typeface="Arial"/>
                         </a:rPr>
@@ -6696,7 +6696,7 @@
                   </a:txBody>
                   <a:tcPr marL="54864" marR="45720" marT="22860" marB="22860">
                     <a:solidFill>
-                      <a:srgbClr val="2A3E52"/>
+                      <a:srgbClr val="DCE8F1"/>
                     </a:solidFill>
                   </a:tcPr>
                 </a:tc>
@@ -6709,7 +6709,7 @@
                       <a:r>
                         <a:rPr sz="1000" b="1">
                           <a:solidFill>
-                            <a:srgbClr val="EBF0F6"/>
+                            <a:srgbClr val="263238"/>
                           </a:solidFill>
                           <a:latin typeface="Arial"/>
                         </a:rPr>
@@ -6719,7 +6719,7 @@
                   </a:txBody>
                   <a:tcPr marL="54864" marR="45720" marT="22860" marB="22860">
                     <a:solidFill>
-                      <a:srgbClr val="2A3E52"/>
+                      <a:srgbClr val="DCE8F1"/>
                     </a:solidFill>
                   </a:tcPr>
                 </a:tc>
@@ -6734,7 +6734,7 @@
                       <a:r>
                         <a:rPr sz="1000" b="0">
                           <a:solidFill>
-                            <a:srgbClr val="ABB9C7"/>
+                            <a:srgbClr val="64748B"/>
                           </a:solidFill>
                           <a:latin typeface="Arial"/>
                         </a:rPr>
@@ -6744,7 +6744,7 @@
                   </a:txBody>
                   <a:tcPr marL="54864" marR="45720" marT="22860" marB="22860">
                     <a:solidFill>
-                      <a:srgbClr val="1C2A3D"/>
+                      <a:srgbClr val="F1F5F9"/>
                     </a:solidFill>
                   </a:tcPr>
                 </a:tc>
@@ -6757,7 +6757,7 @@
                       <a:r>
                         <a:rPr sz="1000" b="0">
                           <a:solidFill>
-                            <a:srgbClr val="ABB9C7"/>
+                            <a:srgbClr val="64748B"/>
                           </a:solidFill>
                           <a:latin typeface="Arial"/>
                         </a:rPr>
@@ -6767,7 +6767,7 @@
                   </a:txBody>
                   <a:tcPr marL="54864" marR="45720" marT="22860" marB="22860">
                     <a:solidFill>
-                      <a:srgbClr val="1C2A3D"/>
+                      <a:srgbClr val="F1F5F9"/>
                     </a:solidFill>
                   </a:tcPr>
                 </a:tc>
@@ -6780,7 +6780,7 @@
                       <a:r>
                         <a:rPr sz="1000" b="0">
                           <a:solidFill>
-                            <a:srgbClr val="ABB9C7"/>
+                            <a:srgbClr val="64748B"/>
                           </a:solidFill>
                           <a:latin typeface="Arial"/>
                         </a:rPr>
@@ -6790,7 +6790,7 @@
                   </a:txBody>
                   <a:tcPr marL="54864" marR="45720" marT="22860" marB="22860">
                     <a:solidFill>
-                      <a:srgbClr val="1C2A3D"/>
+                      <a:srgbClr val="F1F5F9"/>
                     </a:solidFill>
                   </a:tcPr>
                 </a:tc>
@@ -6803,7 +6803,7 @@
                       <a:r>
                         <a:rPr sz="1000" b="0">
                           <a:solidFill>
-                            <a:srgbClr val="ABB9C7"/>
+                            <a:srgbClr val="64748B"/>
                           </a:solidFill>
                           <a:latin typeface="Arial"/>
                         </a:rPr>
@@ -6813,7 +6813,7 @@
                   </a:txBody>
                   <a:tcPr marL="54864" marR="45720" marT="22860" marB="22860">
                     <a:solidFill>
-                      <a:srgbClr val="1C2A3D"/>
+                      <a:srgbClr val="F1F5F9"/>
                     </a:solidFill>
                   </a:tcPr>
                 </a:tc>
@@ -6826,7 +6826,7 @@
                       <a:r>
                         <a:rPr sz="1000" b="0">
                           <a:solidFill>
-                            <a:srgbClr val="ABB9C7"/>
+                            <a:srgbClr val="64748B"/>
                           </a:solidFill>
                           <a:latin typeface="Arial"/>
                         </a:rPr>
@@ -6836,7 +6836,7 @@
                   </a:txBody>
                   <a:tcPr marL="54864" marR="45720" marT="22860" marB="22860">
                     <a:solidFill>
-                      <a:srgbClr val="1C2A3D"/>
+                      <a:srgbClr val="F1F5F9"/>
                     </a:solidFill>
                   </a:tcPr>
                 </a:tc>
@@ -6851,7 +6851,7 @@
                       <a:r>
                         <a:rPr sz="1000" b="0">
                           <a:solidFill>
-                            <a:srgbClr val="ABB9C7"/>
+                            <a:srgbClr val="64748B"/>
                           </a:solidFill>
                           <a:latin typeface="Arial"/>
                         </a:rPr>
@@ -6861,7 +6861,7 @@
                   </a:txBody>
                   <a:tcPr marL="54864" marR="45720" marT="22860" marB="22860">
                     <a:solidFill>
-                      <a:srgbClr val="1C2A3D"/>
+                      <a:srgbClr val="F1F5F9"/>
                     </a:solidFill>
                   </a:tcPr>
                 </a:tc>
@@ -6874,7 +6874,7 @@
                       <a:r>
                         <a:rPr sz="1000" b="0">
                           <a:solidFill>
-                            <a:srgbClr val="ABB9C7"/>
+                            <a:srgbClr val="64748B"/>
                           </a:solidFill>
                           <a:latin typeface="Arial"/>
                         </a:rPr>
@@ -6884,7 +6884,7 @@
                   </a:txBody>
                   <a:tcPr marL="54864" marR="45720" marT="22860" marB="22860">
                     <a:solidFill>
-                      <a:srgbClr val="1C2A3D"/>
+                      <a:srgbClr val="F1F5F9"/>
                     </a:solidFill>
                   </a:tcPr>
                 </a:tc>
@@ -6897,7 +6897,7 @@
                       <a:r>
                         <a:rPr sz="1000" b="0">
                           <a:solidFill>
-                            <a:srgbClr val="ABB9C7"/>
+                            <a:srgbClr val="64748B"/>
                           </a:solidFill>
                           <a:latin typeface="Arial"/>
                         </a:rPr>
@@ -6907,7 +6907,7 @@
                   </a:txBody>
                   <a:tcPr marL="54864" marR="45720" marT="22860" marB="22860">
                     <a:solidFill>
-                      <a:srgbClr val="1C2A3D"/>
+                      <a:srgbClr val="F1F5F9"/>
                     </a:solidFill>
                   </a:tcPr>
                 </a:tc>
@@ -6920,7 +6920,7 @@
                       <a:r>
                         <a:rPr sz="1000" b="0">
                           <a:solidFill>
-                            <a:srgbClr val="ABB9C7"/>
+                            <a:srgbClr val="64748B"/>
                           </a:solidFill>
                           <a:latin typeface="Arial"/>
                         </a:rPr>
@@ -6930,7 +6930,7 @@
                   </a:txBody>
                   <a:tcPr marL="54864" marR="45720" marT="22860" marB="22860">
                     <a:solidFill>
-                      <a:srgbClr val="1C2A3D"/>
+                      <a:srgbClr val="F1F5F9"/>
                     </a:solidFill>
                   </a:tcPr>
                 </a:tc>
@@ -6943,7 +6943,7 @@
                       <a:r>
                         <a:rPr sz="1000" b="0">
                           <a:solidFill>
-                            <a:srgbClr val="ABB9C7"/>
+                            <a:srgbClr val="64748B"/>
                           </a:solidFill>
                           <a:latin typeface="Arial"/>
                         </a:rPr>
@@ -6953,7 +6953,7 @@
                   </a:txBody>
                   <a:tcPr marL="54864" marR="45720" marT="22860" marB="22860">
                     <a:solidFill>
-                      <a:srgbClr val="1C2A3D"/>
+                      <a:srgbClr val="F1F5F9"/>
                     </a:solidFill>
                   </a:tcPr>
                 </a:tc>
@@ -6968,7 +6968,7 @@
                       <a:r>
                         <a:rPr sz="1000" b="0">
                           <a:solidFill>
-                            <a:srgbClr val="ABB9C7"/>
+                            <a:srgbClr val="64748B"/>
                           </a:solidFill>
                           <a:latin typeface="Arial"/>
                         </a:rPr>
@@ -6978,7 +6978,7 @@
                   </a:txBody>
                   <a:tcPr marL="54864" marR="45720" marT="22860" marB="22860">
                     <a:solidFill>
-                      <a:srgbClr val="1C2A3D"/>
+                      <a:srgbClr val="F1F5F9"/>
                     </a:solidFill>
                   </a:tcPr>
                 </a:tc>
@@ -6991,7 +6991,7 @@
                       <a:r>
                         <a:rPr sz="1000" b="0">
                           <a:solidFill>
-                            <a:srgbClr val="ABB9C7"/>
+                            <a:srgbClr val="64748B"/>
                           </a:solidFill>
                           <a:latin typeface="Arial"/>
                         </a:rPr>
@@ -7001,7 +7001,7 @@
                   </a:txBody>
                   <a:tcPr marL="54864" marR="45720" marT="22860" marB="22860">
                     <a:solidFill>
-                      <a:srgbClr val="1C2A3D"/>
+                      <a:srgbClr val="F1F5F9"/>
                     </a:solidFill>
                   </a:tcPr>
                 </a:tc>
@@ -7014,7 +7014,7 @@
                       <a:r>
                         <a:rPr sz="1000" b="0">
                           <a:solidFill>
-                            <a:srgbClr val="ABB9C7"/>
+                            <a:srgbClr val="64748B"/>
                           </a:solidFill>
                           <a:latin typeface="Arial"/>
                         </a:rPr>
@@ -7024,7 +7024,7 @@
                   </a:txBody>
                   <a:tcPr marL="54864" marR="45720" marT="22860" marB="22860">
                     <a:solidFill>
-                      <a:srgbClr val="1C2A3D"/>
+                      <a:srgbClr val="F1F5F9"/>
                     </a:solidFill>
                   </a:tcPr>
                 </a:tc>
@@ -7037,7 +7037,7 @@
                       <a:r>
                         <a:rPr sz="1000" b="0">
                           <a:solidFill>
-                            <a:srgbClr val="ABB9C7"/>
+                            <a:srgbClr val="64748B"/>
                           </a:solidFill>
                           <a:latin typeface="Arial"/>
                         </a:rPr>
@@ -7047,7 +7047,7 @@
                   </a:txBody>
                   <a:tcPr marL="54864" marR="45720" marT="22860" marB="22860">
                     <a:solidFill>
-                      <a:srgbClr val="1C2A3D"/>
+                      <a:srgbClr val="F1F5F9"/>
                     </a:solidFill>
                   </a:tcPr>
                 </a:tc>
@@ -7060,7 +7060,7 @@
                       <a:r>
                         <a:rPr sz="1000" b="0">
                           <a:solidFill>
-                            <a:srgbClr val="ABB9C7"/>
+                            <a:srgbClr val="64748B"/>
                           </a:solidFill>
                           <a:latin typeface="Arial"/>
                         </a:rPr>
@@ -7070,7 +7070,7 @@
                   </a:txBody>
                   <a:tcPr marL="54864" marR="45720" marT="22860" marB="22860">
                     <a:solidFill>
-                      <a:srgbClr val="1C2A3D"/>
+                      <a:srgbClr val="F1F5F9"/>
                     </a:solidFill>
                   </a:tcPr>
                 </a:tc>
@@ -7085,7 +7085,7 @@
                       <a:r>
                         <a:rPr sz="1000" b="0">
                           <a:solidFill>
-                            <a:srgbClr val="ABB9C7"/>
+                            <a:srgbClr val="64748B"/>
                           </a:solidFill>
                           <a:latin typeface="Arial"/>
                         </a:rPr>
@@ -7095,7 +7095,7 @@
                   </a:txBody>
                   <a:tcPr marL="54864" marR="45720" marT="22860" marB="22860">
                     <a:solidFill>
-                      <a:srgbClr val="1C2A3D"/>
+                      <a:srgbClr val="F1F5F9"/>
                     </a:solidFill>
                   </a:tcPr>
                 </a:tc>
@@ -7108,7 +7108,7 @@
                       <a:r>
                         <a:rPr sz="1000" b="0">
                           <a:solidFill>
-                            <a:srgbClr val="ABB9C7"/>
+                            <a:srgbClr val="64748B"/>
                           </a:solidFill>
                           <a:latin typeface="Arial"/>
                         </a:rPr>
@@ -7118,7 +7118,7 @@
                   </a:txBody>
                   <a:tcPr marL="54864" marR="45720" marT="22860" marB="22860">
                     <a:solidFill>
-                      <a:srgbClr val="1C2A3D"/>
+                      <a:srgbClr val="F1F5F9"/>
                     </a:solidFill>
                   </a:tcPr>
                 </a:tc>
@@ -7131,7 +7131,7 @@
                       <a:r>
                         <a:rPr sz="1000" b="0">
                           <a:solidFill>
-                            <a:srgbClr val="ABB9C7"/>
+                            <a:srgbClr val="64748B"/>
                           </a:solidFill>
                           <a:latin typeface="Arial"/>
                         </a:rPr>
@@ -7141,7 +7141,7 @@
                   </a:txBody>
                   <a:tcPr marL="54864" marR="45720" marT="22860" marB="22860">
                     <a:solidFill>
-                      <a:srgbClr val="1C2A3D"/>
+                      <a:srgbClr val="F1F5F9"/>
                     </a:solidFill>
                   </a:tcPr>
                 </a:tc>
@@ -7154,7 +7154,7 @@
                       <a:r>
                         <a:rPr sz="1000" b="0">
                           <a:solidFill>
-                            <a:srgbClr val="ABB9C7"/>
+                            <a:srgbClr val="64748B"/>
                           </a:solidFill>
                           <a:latin typeface="Arial"/>
                         </a:rPr>
@@ -7164,7 +7164,7 @@
                   </a:txBody>
                   <a:tcPr marL="54864" marR="45720" marT="22860" marB="22860">
                     <a:solidFill>
-                      <a:srgbClr val="1C2A3D"/>
+                      <a:srgbClr val="F1F5F9"/>
                     </a:solidFill>
                   </a:tcPr>
                 </a:tc>
@@ -7177,7 +7177,7 @@
                       <a:r>
                         <a:rPr sz="1000" b="0">
                           <a:solidFill>
-                            <a:srgbClr val="ABB9C7"/>
+                            <a:srgbClr val="64748B"/>
                           </a:solidFill>
                           <a:latin typeface="Arial"/>
                         </a:rPr>
@@ -7187,7 +7187,7 @@
                   </a:txBody>
                   <a:tcPr marL="54864" marR="45720" marT="22860" marB="22860">
                     <a:solidFill>
-                      <a:srgbClr val="1C2A3D"/>
+                      <a:srgbClr val="F1F5F9"/>
                     </a:solidFill>
                   </a:tcPr>
                 </a:tc>
@@ -7202,7 +7202,7 @@
                       <a:r>
                         <a:rPr sz="1000" b="0">
                           <a:solidFill>
-                            <a:srgbClr val="ABB9C7"/>
+                            <a:srgbClr val="64748B"/>
                           </a:solidFill>
                           <a:latin typeface="Arial"/>
                         </a:rPr>
@@ -7212,7 +7212,7 @@
                   </a:txBody>
                   <a:tcPr marL="54864" marR="45720" marT="22860" marB="22860">
                     <a:solidFill>
-                      <a:srgbClr val="1C2A3D"/>
+                      <a:srgbClr val="F1F5F9"/>
                     </a:solidFill>
                   </a:tcPr>
                 </a:tc>
@@ -7225,7 +7225,7 @@
                       <a:r>
                         <a:rPr sz="1000" b="0">
                           <a:solidFill>
-                            <a:srgbClr val="ABB9C7"/>
+                            <a:srgbClr val="64748B"/>
                           </a:solidFill>
                           <a:latin typeface="Arial"/>
                         </a:rPr>
@@ -7235,7 +7235,7 @@
                   </a:txBody>
                   <a:tcPr marL="54864" marR="45720" marT="22860" marB="22860">
                     <a:solidFill>
-                      <a:srgbClr val="1C2A3D"/>
+                      <a:srgbClr val="F1F5F9"/>
                     </a:solidFill>
                   </a:tcPr>
                 </a:tc>
@@ -7248,7 +7248,7 @@
                       <a:r>
                         <a:rPr sz="1000" b="0">
                           <a:solidFill>
-                            <a:srgbClr val="ABB9C7"/>
+                            <a:srgbClr val="64748B"/>
                           </a:solidFill>
                           <a:latin typeface="Arial"/>
                         </a:rPr>
@@ -7258,7 +7258,7 @@
                   </a:txBody>
                   <a:tcPr marL="54864" marR="45720" marT="22860" marB="22860">
                     <a:solidFill>
-                      <a:srgbClr val="1C2A3D"/>
+                      <a:srgbClr val="F1F5F9"/>
                     </a:solidFill>
                   </a:tcPr>
                 </a:tc>
@@ -7271,7 +7271,7 @@
                       <a:r>
                         <a:rPr sz="1000" b="0">
                           <a:solidFill>
-                            <a:srgbClr val="ABB9C7"/>
+                            <a:srgbClr val="64748B"/>
                           </a:solidFill>
                           <a:latin typeface="Arial"/>
                         </a:rPr>
@@ -7281,7 +7281,7 @@
                   </a:txBody>
                   <a:tcPr marL="54864" marR="45720" marT="22860" marB="22860">
                     <a:solidFill>
-                      <a:srgbClr val="1C2A3D"/>
+                      <a:srgbClr val="F1F5F9"/>
                     </a:solidFill>
                   </a:tcPr>
                 </a:tc>
@@ -7294,7 +7294,7 @@
                       <a:r>
                         <a:rPr sz="1000" b="0">
                           <a:solidFill>
-                            <a:srgbClr val="ABB9C7"/>
+                            <a:srgbClr val="64748B"/>
                           </a:solidFill>
                           <a:latin typeface="Arial"/>
                         </a:rPr>
@@ -7304,7 +7304,7 @@
                   </a:txBody>
                   <a:tcPr marL="54864" marR="45720" marT="22860" marB="22860">
                     <a:solidFill>
-                      <a:srgbClr val="1C2A3D"/>
+                      <a:srgbClr val="F1F5F9"/>
                     </a:solidFill>
                   </a:tcPr>
                 </a:tc>
@@ -7319,7 +7319,7 @@
                       <a:r>
                         <a:rPr sz="1000" b="0">
                           <a:solidFill>
-                            <a:srgbClr val="ABB9C7"/>
+                            <a:srgbClr val="64748B"/>
                           </a:solidFill>
                           <a:latin typeface="Arial"/>
                         </a:rPr>
@@ -7329,7 +7329,7 @@
                   </a:txBody>
                   <a:tcPr marL="54864" marR="45720" marT="22860" marB="22860">
                     <a:solidFill>
-                      <a:srgbClr val="1C2A3D"/>
+                      <a:srgbClr val="F1F5F9"/>
                     </a:solidFill>
                   </a:tcPr>
                 </a:tc>
@@ -7342,7 +7342,7 @@
                       <a:r>
                         <a:rPr sz="1000" b="0">
                           <a:solidFill>
-                            <a:srgbClr val="ABB9C7"/>
+                            <a:srgbClr val="64748B"/>
                           </a:solidFill>
                           <a:latin typeface="Arial"/>
                         </a:rPr>
@@ -7352,7 +7352,7 @@
                   </a:txBody>
                   <a:tcPr marL="54864" marR="45720" marT="22860" marB="22860">
                     <a:solidFill>
-                      <a:srgbClr val="1C2A3D"/>
+                      <a:srgbClr val="F1F5F9"/>
                     </a:solidFill>
                   </a:tcPr>
                 </a:tc>
@@ -7365,7 +7365,7 @@
                       <a:r>
                         <a:rPr sz="1000" b="0">
                           <a:solidFill>
-                            <a:srgbClr val="ABB9C7"/>
+                            <a:srgbClr val="64748B"/>
                           </a:solidFill>
                           <a:latin typeface="Arial"/>
                         </a:rPr>
@@ -7375,7 +7375,7 @@
                   </a:txBody>
                   <a:tcPr marL="54864" marR="45720" marT="22860" marB="22860">
                     <a:solidFill>
-                      <a:srgbClr val="1C2A3D"/>
+                      <a:srgbClr val="F1F5F9"/>
                     </a:solidFill>
                   </a:tcPr>
                 </a:tc>
@@ -7388,7 +7388,7 @@
                       <a:r>
                         <a:rPr sz="1000" b="0">
                           <a:solidFill>
-                            <a:srgbClr val="ABB9C7"/>
+                            <a:srgbClr val="64748B"/>
                           </a:solidFill>
                           <a:latin typeface="Arial"/>
                         </a:rPr>
@@ -7398,7 +7398,7 @@
                   </a:txBody>
                   <a:tcPr marL="54864" marR="45720" marT="22860" marB="22860">
                     <a:solidFill>
-                      <a:srgbClr val="1C2A3D"/>
+                      <a:srgbClr val="F1F5F9"/>
                     </a:solidFill>
                   </a:tcPr>
                 </a:tc>
@@ -7411,7 +7411,7 @@
                       <a:r>
                         <a:rPr sz="1000" b="0">
                           <a:solidFill>
-                            <a:srgbClr val="ABB9C7"/>
+                            <a:srgbClr val="64748B"/>
                           </a:solidFill>
                           <a:latin typeface="Arial"/>
                         </a:rPr>
@@ -7421,7 +7421,7 @@
                   </a:txBody>
                   <a:tcPr marL="54864" marR="45720" marT="22860" marB="22860">
                     <a:solidFill>
-                      <a:srgbClr val="1C2A3D"/>
+                      <a:srgbClr val="F1F5F9"/>
                     </a:solidFill>
                   </a:tcPr>
                 </a:tc>
@@ -7436,7 +7436,7 @@
                       <a:r>
                         <a:rPr sz="1000" b="0">
                           <a:solidFill>
-                            <a:srgbClr val="ABB9C7"/>
+                            <a:srgbClr val="64748B"/>
                           </a:solidFill>
                           <a:latin typeface="Arial"/>
                         </a:rPr>
@@ -7446,7 +7446,7 @@
                   </a:txBody>
                   <a:tcPr marL="54864" marR="45720" marT="22860" marB="22860">
                     <a:solidFill>
-                      <a:srgbClr val="1C2A3D"/>
+                      <a:srgbClr val="F1F5F9"/>
                     </a:solidFill>
                   </a:tcPr>
                 </a:tc>
@@ -7459,7 +7459,7 @@
                       <a:r>
                         <a:rPr sz="1000" b="0">
                           <a:solidFill>
-                            <a:srgbClr val="ABB9C7"/>
+                            <a:srgbClr val="64748B"/>
                           </a:solidFill>
                           <a:latin typeface="Arial"/>
                         </a:rPr>
@@ -7469,7 +7469,7 @@
                   </a:txBody>
                   <a:tcPr marL="54864" marR="45720" marT="22860" marB="22860">
                     <a:solidFill>
-                      <a:srgbClr val="1C2A3D"/>
+                      <a:srgbClr val="F1F5F9"/>
                     </a:solidFill>
                   </a:tcPr>
                 </a:tc>
@@ -7482,7 +7482,7 @@
                       <a:r>
                         <a:rPr sz="1000" b="0">
                           <a:solidFill>
-                            <a:srgbClr val="ABB9C7"/>
+                            <a:srgbClr val="64748B"/>
                           </a:solidFill>
                           <a:latin typeface="Arial"/>
                         </a:rPr>
@@ -7492,7 +7492,7 @@
                   </a:txBody>
                   <a:tcPr marL="54864" marR="45720" marT="22860" marB="22860">
                     <a:solidFill>
-                      <a:srgbClr val="1C2A3D"/>
+                      <a:srgbClr val="F1F5F9"/>
                     </a:solidFill>
                   </a:tcPr>
                 </a:tc>
@@ -7505,7 +7505,7 @@
                       <a:r>
                         <a:rPr sz="1000" b="0">
                           <a:solidFill>
-                            <a:srgbClr val="ABB9C7"/>
+                            <a:srgbClr val="64748B"/>
                           </a:solidFill>
                           <a:latin typeface="Arial"/>
                         </a:rPr>
@@ -7515,7 +7515,7 @@
                   </a:txBody>
                   <a:tcPr marL="54864" marR="45720" marT="22860" marB="22860">
                     <a:solidFill>
-                      <a:srgbClr val="1C2A3D"/>
+                      <a:srgbClr val="F1F5F9"/>
                     </a:solidFill>
                   </a:tcPr>
                 </a:tc>
@@ -7528,7 +7528,7 @@
                       <a:r>
                         <a:rPr sz="1000" b="0">
                           <a:solidFill>
-                            <a:srgbClr val="ABB9C7"/>
+                            <a:srgbClr val="64748B"/>
                           </a:solidFill>
                           <a:latin typeface="Arial"/>
                         </a:rPr>
@@ -7538,7 +7538,7 @@
                   </a:txBody>
                   <a:tcPr marL="54864" marR="45720" marT="22860" marB="22860">
                     <a:solidFill>
-                      <a:srgbClr val="1C2A3D"/>
+                      <a:srgbClr val="F1F5F9"/>
                     </a:solidFill>
                   </a:tcPr>
                 </a:tc>
@@ -7553,7 +7553,7 @@
                       <a:r>
                         <a:rPr sz="1000" b="0">
                           <a:solidFill>
-                            <a:srgbClr val="ABB9C7"/>
+                            <a:srgbClr val="64748B"/>
                           </a:solidFill>
                           <a:latin typeface="Arial"/>
                         </a:rPr>
@@ -7563,7 +7563,7 @@
                   </a:txBody>
                   <a:tcPr marL="54864" marR="45720" marT="22860" marB="22860">
                     <a:solidFill>
-                      <a:srgbClr val="1C2A3D"/>
+                      <a:srgbClr val="F1F5F9"/>
                     </a:solidFill>
                   </a:tcPr>
                 </a:tc>
@@ -7576,7 +7576,7 @@
                       <a:r>
                         <a:rPr sz="1000" b="0">
                           <a:solidFill>
-                            <a:srgbClr val="ABB9C7"/>
+                            <a:srgbClr val="64748B"/>
                           </a:solidFill>
                           <a:latin typeface="Arial"/>
                         </a:rPr>
@@ -7586,7 +7586,7 @@
                   </a:txBody>
                   <a:tcPr marL="54864" marR="45720" marT="22860" marB="22860">
                     <a:solidFill>
-                      <a:srgbClr val="1C2A3D"/>
+                      <a:srgbClr val="F1F5F9"/>
                     </a:solidFill>
                   </a:tcPr>
                 </a:tc>
@@ -7599,7 +7599,7 @@
                       <a:r>
                         <a:rPr sz="1000" b="0">
                           <a:solidFill>
-                            <a:srgbClr val="ABB9C7"/>
+                            <a:srgbClr val="64748B"/>
                           </a:solidFill>
                           <a:latin typeface="Arial"/>
                         </a:rPr>
@@ -7609,7 +7609,7 @@
                   </a:txBody>
                   <a:tcPr marL="54864" marR="45720" marT="22860" marB="22860">
                     <a:solidFill>
-                      <a:srgbClr val="1C2A3D"/>
+                      <a:srgbClr val="F1F5F9"/>
                     </a:solidFill>
                   </a:tcPr>
                 </a:tc>
@@ -7622,7 +7622,7 @@
                       <a:r>
                         <a:rPr sz="1000" b="0">
                           <a:solidFill>
-                            <a:srgbClr val="ABB9C7"/>
+                            <a:srgbClr val="64748B"/>
                           </a:solidFill>
                           <a:latin typeface="Arial"/>
                         </a:rPr>
@@ -7632,7 +7632,7 @@
                   </a:txBody>
                   <a:tcPr marL="54864" marR="45720" marT="22860" marB="22860">
                     <a:solidFill>
-                      <a:srgbClr val="1C2A3D"/>
+                      <a:srgbClr val="F1F5F9"/>
                     </a:solidFill>
                   </a:tcPr>
                 </a:tc>
@@ -7645,7 +7645,7 @@
                       <a:r>
                         <a:rPr sz="1000" b="0">
                           <a:solidFill>
-                            <a:srgbClr val="ABB9C7"/>
+                            <a:srgbClr val="64748B"/>
                           </a:solidFill>
                           <a:latin typeface="Arial"/>
                         </a:rPr>
@@ -7655,7 +7655,7 @@
                   </a:txBody>
                   <a:tcPr marL="54864" marR="45720" marT="22860" marB="22860">
                     <a:solidFill>
-                      <a:srgbClr val="1C2A3D"/>
+                      <a:srgbClr val="F1F5F9"/>
                     </a:solidFill>
                   </a:tcPr>
                 </a:tc>
@@ -7694,7 +7694,7 @@
             <a:r>
               <a:rPr sz="900" b="0">
                 <a:solidFill>
-                  <a:srgbClr val="ABB9C7"/>
+                  <a:srgbClr val="64748B"/>
                 </a:solidFill>
                 <a:latin typeface="Arial"/>
               </a:rPr>
@@ -7736,7 +7736,7 @@
             <a:avLst/>
           </a:prstGeom>
           <a:solidFill>
-            <a:srgbClr val="121B2A"/>
+            <a:srgbClr val="FFFFFF"/>
           </a:solidFill>
           <a:ln>
             <a:noFill/>
@@ -7794,7 +7794,7 @@
             <a:r>
               <a:rPr sz="1000" b="1">
                 <a:solidFill>
-                  <a:srgbClr val="4AB8A7"/>
+                  <a:srgbClr val="2E6F9E"/>
                 </a:solidFill>
                 <a:latin typeface="Arial"/>
               </a:rPr>
@@ -7833,7 +7833,7 @@
             <a:r>
               <a:rPr sz="2600" b="1">
                 <a:solidFill>
-                  <a:srgbClr val="EBF0F6"/>
+                  <a:srgbClr val="263238"/>
                 </a:solidFill>
                 <a:latin typeface="Arial"/>
               </a:rPr>
@@ -7872,7 +7872,7 @@
             <a:r>
               <a:rPr sz="1200" b="0">
                 <a:solidFill>
-                  <a:srgbClr val="ABB9C7"/>
+                  <a:srgbClr val="64748B"/>
                 </a:solidFill>
                 <a:latin typeface="Arial"/>
               </a:rPr>
@@ -7896,7 +7896,7 @@
             <a:avLst/>
           </a:prstGeom>
           <a:solidFill>
-            <a:srgbClr val="1C2A3D"/>
+            <a:srgbClr val="F1F5F9"/>
           </a:solidFill>
           <a:ln>
             <a:noFill/>
@@ -7954,7 +7954,7 @@
             <a:r>
               <a:rPr sz="900" b="0">
                 <a:solidFill>
-                  <a:srgbClr val="ABB9C7"/>
+                  <a:srgbClr val="64748B"/>
                 </a:solidFill>
                 <a:latin typeface="Arial"/>
               </a:rPr>
@@ -7993,7 +7993,7 @@
             <a:r>
               <a:rPr sz="1000" b="0">
                 <a:solidFill>
-                  <a:srgbClr val="ABB9C7"/>
+                  <a:srgbClr val="64748B"/>
                 </a:solidFill>
                 <a:latin typeface="Arial"/>
               </a:rPr>
@@ -8040,7 +8040,7 @@
                       <a:r>
                         <a:rPr sz="850" b="1">
                           <a:solidFill>
-                            <a:srgbClr val="EBF0F6"/>
+                            <a:srgbClr val="263238"/>
                           </a:solidFill>
                           <a:latin typeface="Arial"/>
                         </a:rPr>
@@ -8050,7 +8050,7 @@
                   </a:txBody>
                   <a:tcPr marL="54864" marR="45720" marT="22860" marB="22860">
                     <a:solidFill>
-                      <a:srgbClr val="2A3E52"/>
+                      <a:srgbClr val="DCE8F1"/>
                     </a:solidFill>
                   </a:tcPr>
                 </a:tc>
@@ -8063,7 +8063,7 @@
                       <a:r>
                         <a:rPr sz="850" b="1">
                           <a:solidFill>
-                            <a:srgbClr val="EBF0F6"/>
+                            <a:srgbClr val="263238"/>
                           </a:solidFill>
                           <a:latin typeface="Arial"/>
                         </a:rPr>
@@ -8073,7 +8073,7 @@
                   </a:txBody>
                   <a:tcPr marL="54864" marR="45720" marT="22860" marB="22860">
                     <a:solidFill>
-                      <a:srgbClr val="2A3E52"/>
+                      <a:srgbClr val="DCE8F1"/>
                     </a:solidFill>
                   </a:tcPr>
                 </a:tc>
@@ -8086,7 +8086,7 @@
                       <a:r>
                         <a:rPr sz="850" b="1">
                           <a:solidFill>
-                            <a:srgbClr val="EBF0F6"/>
+                            <a:srgbClr val="263238"/>
                           </a:solidFill>
                           <a:latin typeface="Arial"/>
                         </a:rPr>
@@ -8096,7 +8096,7 @@
                   </a:txBody>
                   <a:tcPr marL="54864" marR="45720" marT="22860" marB="22860">
                     <a:solidFill>
-                      <a:srgbClr val="2A3E52"/>
+                      <a:srgbClr val="DCE8F1"/>
                     </a:solidFill>
                   </a:tcPr>
                 </a:tc>
@@ -8109,7 +8109,7 @@
                       <a:r>
                         <a:rPr sz="850" b="1">
                           <a:solidFill>
-                            <a:srgbClr val="EBF0F6"/>
+                            <a:srgbClr val="263238"/>
                           </a:solidFill>
                           <a:latin typeface="Arial"/>
                         </a:rPr>
@@ -8119,7 +8119,7 @@
                   </a:txBody>
                   <a:tcPr marL="54864" marR="45720" marT="22860" marB="22860">
                     <a:solidFill>
-                      <a:srgbClr val="2A3E52"/>
+                      <a:srgbClr val="DCE8F1"/>
                     </a:solidFill>
                   </a:tcPr>
                 </a:tc>
@@ -8132,7 +8132,7 @@
                       <a:r>
                         <a:rPr sz="850" b="1">
                           <a:solidFill>
-                            <a:srgbClr val="EBF0F6"/>
+                            <a:srgbClr val="263238"/>
                           </a:solidFill>
                           <a:latin typeface="Arial"/>
                         </a:rPr>
@@ -8142,7 +8142,7 @@
                   </a:txBody>
                   <a:tcPr marL="54864" marR="45720" marT="22860" marB="22860">
                     <a:solidFill>
-                      <a:srgbClr val="2A3E52"/>
+                      <a:srgbClr val="DCE8F1"/>
                     </a:solidFill>
                   </a:tcPr>
                 </a:tc>
@@ -8155,7 +8155,7 @@
                       <a:r>
                         <a:rPr sz="850" b="1">
                           <a:solidFill>
-                            <a:srgbClr val="EBF0F6"/>
+                            <a:srgbClr val="263238"/>
                           </a:solidFill>
                           <a:latin typeface="Arial"/>
                         </a:rPr>
@@ -8165,7 +8165,7 @@
                   </a:txBody>
                   <a:tcPr marL="54864" marR="45720" marT="22860" marB="22860">
                     <a:solidFill>
-                      <a:srgbClr val="2A3E52"/>
+                      <a:srgbClr val="DCE8F1"/>
                     </a:solidFill>
                   </a:tcPr>
                 </a:tc>
@@ -8178,7 +8178,7 @@
                       <a:r>
                         <a:rPr sz="850" b="1">
                           <a:solidFill>
-                            <a:srgbClr val="EBF0F6"/>
+                            <a:srgbClr val="263238"/>
                           </a:solidFill>
                           <a:latin typeface="Arial"/>
                         </a:rPr>
@@ -8188,7 +8188,7 @@
                   </a:txBody>
                   <a:tcPr marL="54864" marR="45720" marT="22860" marB="22860">
                     <a:solidFill>
-                      <a:srgbClr val="2A3E52"/>
+                      <a:srgbClr val="DCE8F1"/>
                     </a:solidFill>
                   </a:tcPr>
                 </a:tc>
@@ -8201,7 +8201,7 @@
                       <a:r>
                         <a:rPr sz="850" b="1">
                           <a:solidFill>
-                            <a:srgbClr val="EBF0F6"/>
+                            <a:srgbClr val="263238"/>
                           </a:solidFill>
                           <a:latin typeface="Arial"/>
                         </a:rPr>
@@ -8211,7 +8211,7 @@
                   </a:txBody>
                   <a:tcPr marL="54864" marR="45720" marT="22860" marB="22860">
                     <a:solidFill>
-                      <a:srgbClr val="2A3E52"/>
+                      <a:srgbClr val="DCE8F1"/>
                     </a:solidFill>
                   </a:tcPr>
                 </a:tc>
@@ -8226,7 +8226,7 @@
                       <a:r>
                         <a:rPr sz="850" b="0">
                           <a:solidFill>
-                            <a:srgbClr val="ABB9C7"/>
+                            <a:srgbClr val="64748B"/>
                           </a:solidFill>
                           <a:latin typeface="Arial"/>
                         </a:rPr>
@@ -8236,7 +8236,7 @@
                   </a:txBody>
                   <a:tcPr marL="54864" marR="45720" marT="22860" marB="22860">
                     <a:solidFill>
-                      <a:srgbClr val="1C2A3D"/>
+                      <a:srgbClr val="F1F5F9"/>
                     </a:solidFill>
                   </a:tcPr>
                 </a:tc>
@@ -8249,7 +8249,7 @@
                       <a:r>
                         <a:rPr sz="850" b="0">
                           <a:solidFill>
-                            <a:srgbClr val="ABB9C7"/>
+                            <a:srgbClr val="64748B"/>
                           </a:solidFill>
                           <a:latin typeface="Arial"/>
                         </a:rPr>
@@ -8259,7 +8259,7 @@
                   </a:txBody>
                   <a:tcPr marL="54864" marR="45720" marT="22860" marB="22860">
                     <a:solidFill>
-                      <a:srgbClr val="1C2A3D"/>
+                      <a:srgbClr val="F1F5F9"/>
                     </a:solidFill>
                   </a:tcPr>
                 </a:tc>
@@ -8272,7 +8272,7 @@
                       <a:r>
                         <a:rPr sz="850" b="0">
                           <a:solidFill>
-                            <a:srgbClr val="ABB9C7"/>
+                            <a:srgbClr val="64748B"/>
                           </a:solidFill>
                           <a:latin typeface="Arial"/>
                         </a:rPr>
@@ -8282,7 +8282,7 @@
                   </a:txBody>
                   <a:tcPr marL="54864" marR="45720" marT="22860" marB="22860">
                     <a:solidFill>
-                      <a:srgbClr val="1C2A3D"/>
+                      <a:srgbClr val="F1F5F9"/>
                     </a:solidFill>
                   </a:tcPr>
                 </a:tc>
@@ -8295,7 +8295,7 @@
                       <a:r>
                         <a:rPr sz="850" b="0">
                           <a:solidFill>
-                            <a:srgbClr val="ABB9C7"/>
+                            <a:srgbClr val="64748B"/>
                           </a:solidFill>
                           <a:latin typeface="Arial"/>
                         </a:rPr>
@@ -8305,7 +8305,7 @@
                   </a:txBody>
                   <a:tcPr marL="54864" marR="45720" marT="22860" marB="22860">
                     <a:solidFill>
-                      <a:srgbClr val="1C2A3D"/>
+                      <a:srgbClr val="F1F5F9"/>
                     </a:solidFill>
                   </a:tcPr>
                 </a:tc>
@@ -8318,7 +8318,7 @@
                       <a:r>
                         <a:rPr sz="850" b="0">
                           <a:solidFill>
-                            <a:srgbClr val="ABB9C7"/>
+                            <a:srgbClr val="64748B"/>
                           </a:solidFill>
                           <a:latin typeface="Arial"/>
                         </a:rPr>
@@ -8328,7 +8328,7 @@
                   </a:txBody>
                   <a:tcPr marL="54864" marR="45720" marT="22860" marB="22860">
                     <a:solidFill>
-                      <a:srgbClr val="1C2A3D"/>
+                      <a:srgbClr val="F1F5F9"/>
                     </a:solidFill>
                   </a:tcPr>
                 </a:tc>
@@ -8341,7 +8341,7 @@
                       <a:r>
                         <a:rPr sz="850" b="0">
                           <a:solidFill>
-                            <a:srgbClr val="ABB9C7"/>
+                            <a:srgbClr val="64748B"/>
                           </a:solidFill>
                           <a:latin typeface="Arial"/>
                         </a:rPr>
@@ -8351,7 +8351,7 @@
                   </a:txBody>
                   <a:tcPr marL="54864" marR="45720" marT="22860" marB="22860">
                     <a:solidFill>
-                      <a:srgbClr val="1C2A3D"/>
+                      <a:srgbClr val="F1F5F9"/>
                     </a:solidFill>
                   </a:tcPr>
                 </a:tc>
@@ -8364,7 +8364,7 @@
                       <a:r>
                         <a:rPr sz="850" b="0">
                           <a:solidFill>
-                            <a:srgbClr val="ABB9C7"/>
+                            <a:srgbClr val="64748B"/>
                           </a:solidFill>
                           <a:latin typeface="Arial"/>
                         </a:rPr>
@@ -8374,7 +8374,7 @@
                   </a:txBody>
                   <a:tcPr marL="54864" marR="45720" marT="22860" marB="22860">
                     <a:solidFill>
-                      <a:srgbClr val="1C2A3D"/>
+                      <a:srgbClr val="F1F5F9"/>
                     </a:solidFill>
                   </a:tcPr>
                 </a:tc>
@@ -8387,7 +8387,7 @@
                       <a:r>
                         <a:rPr sz="850" b="0">
                           <a:solidFill>
-                            <a:srgbClr val="ABB9C7"/>
+                            <a:srgbClr val="64748B"/>
                           </a:solidFill>
                           <a:latin typeface="Arial"/>
                         </a:rPr>
@@ -8397,7 +8397,7 @@
                   </a:txBody>
                   <a:tcPr marL="54864" marR="45720" marT="22860" marB="22860">
                     <a:solidFill>
-                      <a:srgbClr val="1C2A3D"/>
+                      <a:srgbClr val="F1F5F9"/>
                     </a:solidFill>
                   </a:tcPr>
                 </a:tc>
@@ -8412,7 +8412,7 @@
                       <a:r>
                         <a:rPr sz="850" b="0">
                           <a:solidFill>
-                            <a:srgbClr val="ABB9C7"/>
+                            <a:srgbClr val="64748B"/>
                           </a:solidFill>
                           <a:latin typeface="Arial"/>
                         </a:rPr>
@@ -8422,7 +8422,7 @@
                   </a:txBody>
                   <a:tcPr marL="54864" marR="45720" marT="22860" marB="22860">
                     <a:solidFill>
-                      <a:srgbClr val="1C2A3D"/>
+                      <a:srgbClr val="F1F5F9"/>
                     </a:solidFill>
                   </a:tcPr>
                 </a:tc>
@@ -8435,7 +8435,7 @@
                       <a:r>
                         <a:rPr sz="850" b="0">
                           <a:solidFill>
-                            <a:srgbClr val="ABB9C7"/>
+                            <a:srgbClr val="64748B"/>
                           </a:solidFill>
                           <a:latin typeface="Arial"/>
                         </a:rPr>
@@ -8445,7 +8445,7 @@
                   </a:txBody>
                   <a:tcPr marL="54864" marR="45720" marT="22860" marB="22860">
                     <a:solidFill>
-                      <a:srgbClr val="1C2A3D"/>
+                      <a:srgbClr val="F1F5F9"/>
                     </a:solidFill>
                   </a:tcPr>
                 </a:tc>
@@ -8458,7 +8458,7 @@
                       <a:r>
                         <a:rPr sz="850" b="0">
                           <a:solidFill>
-                            <a:srgbClr val="ABB9C7"/>
+                            <a:srgbClr val="64748B"/>
                           </a:solidFill>
                           <a:latin typeface="Arial"/>
                         </a:rPr>
@@ -8468,7 +8468,7 @@
                   </a:txBody>
                   <a:tcPr marL="54864" marR="45720" marT="22860" marB="22860">
                     <a:solidFill>
-                      <a:srgbClr val="1C2A3D"/>
+                      <a:srgbClr val="F1F5F9"/>
                     </a:solidFill>
                   </a:tcPr>
                 </a:tc>
@@ -8481,7 +8481,7 @@
                       <a:r>
                         <a:rPr sz="850" b="0">
                           <a:solidFill>
-                            <a:srgbClr val="ABB9C7"/>
+                            <a:srgbClr val="64748B"/>
                           </a:solidFill>
                           <a:latin typeface="Arial"/>
                         </a:rPr>
@@ -8491,7 +8491,7 @@
                   </a:txBody>
                   <a:tcPr marL="54864" marR="45720" marT="22860" marB="22860">
                     <a:solidFill>
-                      <a:srgbClr val="1C2A3D"/>
+                      <a:srgbClr val="F1F5F9"/>
                     </a:solidFill>
                   </a:tcPr>
                 </a:tc>
@@ -8504,7 +8504,7 @@
                       <a:r>
                         <a:rPr sz="850" b="0">
                           <a:solidFill>
-                            <a:srgbClr val="ABB9C7"/>
+                            <a:srgbClr val="64748B"/>
                           </a:solidFill>
                           <a:latin typeface="Arial"/>
                         </a:rPr>
@@ -8514,7 +8514,7 @@
                   </a:txBody>
                   <a:tcPr marL="54864" marR="45720" marT="22860" marB="22860">
                     <a:solidFill>
-                      <a:srgbClr val="1C2A3D"/>
+                      <a:srgbClr val="F1F5F9"/>
                     </a:solidFill>
                   </a:tcPr>
                 </a:tc>
@@ -8527,7 +8527,7 @@
                       <a:r>
                         <a:rPr sz="850" b="0">
                           <a:solidFill>
-                            <a:srgbClr val="ABB9C7"/>
+                            <a:srgbClr val="64748B"/>
                           </a:solidFill>
                           <a:latin typeface="Arial"/>
                         </a:rPr>
@@ -8537,7 +8537,7 @@
                   </a:txBody>
                   <a:tcPr marL="54864" marR="45720" marT="22860" marB="22860">
                     <a:solidFill>
-                      <a:srgbClr val="1C2A3D"/>
+                      <a:srgbClr val="F1F5F9"/>
                     </a:solidFill>
                   </a:tcPr>
                 </a:tc>
@@ -8550,7 +8550,7 @@
                       <a:r>
                         <a:rPr sz="850" b="0">
                           <a:solidFill>
-                            <a:srgbClr val="ABB9C7"/>
+                            <a:srgbClr val="64748B"/>
                           </a:solidFill>
                           <a:latin typeface="Arial"/>
                         </a:rPr>
@@ -8560,7 +8560,7 @@
                   </a:txBody>
                   <a:tcPr marL="54864" marR="45720" marT="22860" marB="22860">
                     <a:solidFill>
-                      <a:srgbClr val="1C2A3D"/>
+                      <a:srgbClr val="F1F5F9"/>
                     </a:solidFill>
                   </a:tcPr>
                 </a:tc>
@@ -8573,7 +8573,7 @@
                       <a:r>
                         <a:rPr sz="850" b="0">
                           <a:solidFill>
-                            <a:srgbClr val="ABB9C7"/>
+                            <a:srgbClr val="64748B"/>
                           </a:solidFill>
                           <a:latin typeface="Arial"/>
                         </a:rPr>
@@ -8583,7 +8583,7 @@
                   </a:txBody>
                   <a:tcPr marL="54864" marR="45720" marT="22860" marB="22860">
                     <a:solidFill>
-                      <a:srgbClr val="1C2A3D"/>
+                      <a:srgbClr val="F1F5F9"/>
                     </a:solidFill>
                   </a:tcPr>
                 </a:tc>
@@ -8598,7 +8598,7 @@
                       <a:r>
                         <a:rPr sz="850" b="0">
                           <a:solidFill>
-                            <a:srgbClr val="ABB9C7"/>
+                            <a:srgbClr val="64748B"/>
                           </a:solidFill>
                           <a:latin typeface="Arial"/>
                         </a:rPr>
@@ -8608,7 +8608,7 @@
                   </a:txBody>
                   <a:tcPr marL="54864" marR="45720" marT="22860" marB="22860">
                     <a:solidFill>
-                      <a:srgbClr val="1C2A3D"/>
+                      <a:srgbClr val="F1F5F9"/>
                     </a:solidFill>
                   </a:tcPr>
                 </a:tc>
@@ -8621,7 +8621,7 @@
                       <a:r>
                         <a:rPr sz="850" b="0">
                           <a:solidFill>
-                            <a:srgbClr val="ABB9C7"/>
+                            <a:srgbClr val="64748B"/>
                           </a:solidFill>
                           <a:latin typeface="Arial"/>
                         </a:rPr>
@@ -8631,7 +8631,7 @@
                   </a:txBody>
                   <a:tcPr marL="54864" marR="45720" marT="22860" marB="22860">
                     <a:solidFill>
-                      <a:srgbClr val="1C2A3D"/>
+                      <a:srgbClr val="F1F5F9"/>
                     </a:solidFill>
                   </a:tcPr>
                 </a:tc>
@@ -8644,7 +8644,7 @@
                       <a:r>
                         <a:rPr sz="850" b="0">
                           <a:solidFill>
-                            <a:srgbClr val="ABB9C7"/>
+                            <a:srgbClr val="64748B"/>
                           </a:solidFill>
                           <a:latin typeface="Arial"/>
                         </a:rPr>
@@ -8654,7 +8654,7 @@
                   </a:txBody>
                   <a:tcPr marL="54864" marR="45720" marT="22860" marB="22860">
                     <a:solidFill>
-                      <a:srgbClr val="1C2A3D"/>
+                      <a:srgbClr val="F1F5F9"/>
                     </a:solidFill>
                   </a:tcPr>
                 </a:tc>
@@ -8667,7 +8667,7 @@
                       <a:r>
                         <a:rPr sz="850" b="0">
                           <a:solidFill>
-                            <a:srgbClr val="ABB9C7"/>
+                            <a:srgbClr val="64748B"/>
                           </a:solidFill>
                           <a:latin typeface="Arial"/>
                         </a:rPr>
@@ -8677,7 +8677,7 @@
                   </a:txBody>
                   <a:tcPr marL="54864" marR="45720" marT="22860" marB="22860">
                     <a:solidFill>
-                      <a:srgbClr val="1C2A3D"/>
+                      <a:srgbClr val="F1F5F9"/>
                     </a:solidFill>
                   </a:tcPr>
                 </a:tc>
@@ -8690,7 +8690,7 @@
                       <a:r>
                         <a:rPr sz="850" b="0">
                           <a:solidFill>
-                            <a:srgbClr val="ABB9C7"/>
+                            <a:srgbClr val="64748B"/>
                           </a:solidFill>
                           <a:latin typeface="Arial"/>
                         </a:rPr>
@@ -8700,7 +8700,7 @@
                   </a:txBody>
                   <a:tcPr marL="54864" marR="45720" marT="22860" marB="22860">
                     <a:solidFill>
-                      <a:srgbClr val="1C2A3D"/>
+                      <a:srgbClr val="F1F5F9"/>
                     </a:solidFill>
                   </a:tcPr>
                 </a:tc>
@@ -8713,7 +8713,7 @@
                       <a:r>
                         <a:rPr sz="850" b="0">
                           <a:solidFill>
-                            <a:srgbClr val="ABB9C7"/>
+                            <a:srgbClr val="64748B"/>
                           </a:solidFill>
                           <a:latin typeface="Arial"/>
                         </a:rPr>
@@ -8723,7 +8723,7 @@
                   </a:txBody>
                   <a:tcPr marL="54864" marR="45720" marT="22860" marB="22860">
                     <a:solidFill>
-                      <a:srgbClr val="1C2A3D"/>
+                      <a:srgbClr val="F1F5F9"/>
                     </a:solidFill>
                   </a:tcPr>
                 </a:tc>
@@ -8736,7 +8736,7 @@
                       <a:r>
                         <a:rPr sz="850" b="0">
                           <a:solidFill>
-                            <a:srgbClr val="ABB9C7"/>
+                            <a:srgbClr val="64748B"/>
                           </a:solidFill>
                           <a:latin typeface="Arial"/>
                         </a:rPr>
@@ -8746,7 +8746,7 @@
                   </a:txBody>
                   <a:tcPr marL="54864" marR="45720" marT="22860" marB="22860">
                     <a:solidFill>
-                      <a:srgbClr val="1C2A3D"/>
+                      <a:srgbClr val="F1F5F9"/>
                     </a:solidFill>
                   </a:tcPr>
                 </a:tc>
@@ -8759,7 +8759,7 @@
                       <a:r>
                         <a:rPr sz="850" b="0">
                           <a:solidFill>
-                            <a:srgbClr val="ABB9C7"/>
+                            <a:srgbClr val="64748B"/>
                           </a:solidFill>
                           <a:latin typeface="Arial"/>
                         </a:rPr>
@@ -8769,7 +8769,7 @@
                   </a:txBody>
                   <a:tcPr marL="54864" marR="45720" marT="22860" marB="22860">
                     <a:solidFill>
-                      <a:srgbClr val="1C2A3D"/>
+                      <a:srgbClr val="F1F5F9"/>
                     </a:solidFill>
                   </a:tcPr>
                 </a:tc>
@@ -8784,7 +8784,7 @@
                       <a:r>
                         <a:rPr sz="850" b="0">
                           <a:solidFill>
-                            <a:srgbClr val="ABB9C7"/>
+                            <a:srgbClr val="64748B"/>
                           </a:solidFill>
                           <a:latin typeface="Arial"/>
                         </a:rPr>
@@ -8794,7 +8794,7 @@
                   </a:txBody>
                   <a:tcPr marL="54864" marR="45720" marT="22860" marB="22860">
                     <a:solidFill>
-                      <a:srgbClr val="1C2A3D"/>
+                      <a:srgbClr val="F1F5F9"/>
                     </a:solidFill>
                   </a:tcPr>
                 </a:tc>
@@ -8807,7 +8807,7 @@
                       <a:r>
                         <a:rPr sz="850" b="0">
                           <a:solidFill>
-                            <a:srgbClr val="ABB9C7"/>
+                            <a:srgbClr val="64748B"/>
                           </a:solidFill>
                           <a:latin typeface="Arial"/>
                         </a:rPr>
@@ -8817,7 +8817,7 @@
                   </a:txBody>
                   <a:tcPr marL="54864" marR="45720" marT="22860" marB="22860">
                     <a:solidFill>
-                      <a:srgbClr val="1C2A3D"/>
+                      <a:srgbClr val="F1F5F9"/>
                     </a:solidFill>
                   </a:tcPr>
                 </a:tc>
@@ -8830,7 +8830,7 @@
                       <a:r>
                         <a:rPr sz="850" b="0">
                           <a:solidFill>
-                            <a:srgbClr val="ABB9C7"/>
+                            <a:srgbClr val="64748B"/>
                           </a:solidFill>
                           <a:latin typeface="Arial"/>
                         </a:rPr>
@@ -8840,7 +8840,7 @@
                   </a:txBody>
                   <a:tcPr marL="54864" marR="45720" marT="22860" marB="22860">
                     <a:solidFill>
-                      <a:srgbClr val="1C2A3D"/>
+                      <a:srgbClr val="F1F5F9"/>
                     </a:solidFill>
                   </a:tcPr>
                 </a:tc>
@@ -8853,7 +8853,7 @@
                       <a:r>
                         <a:rPr sz="850" b="0">
                           <a:solidFill>
-                            <a:srgbClr val="ABB9C7"/>
+                            <a:srgbClr val="64748B"/>
                           </a:solidFill>
                           <a:latin typeface="Arial"/>
                         </a:rPr>
@@ -8863,7 +8863,7 @@
                   </a:txBody>
                   <a:tcPr marL="54864" marR="45720" marT="22860" marB="22860">
                     <a:solidFill>
-                      <a:srgbClr val="1C2A3D"/>
+                      <a:srgbClr val="F1F5F9"/>
                     </a:solidFill>
                   </a:tcPr>
                 </a:tc>
@@ -8876,7 +8876,7 @@
                       <a:r>
                         <a:rPr sz="850" b="0">
                           <a:solidFill>
-                            <a:srgbClr val="ABB9C7"/>
+                            <a:srgbClr val="64748B"/>
                           </a:solidFill>
                           <a:latin typeface="Arial"/>
                         </a:rPr>
@@ -8886,7 +8886,7 @@
                   </a:txBody>
                   <a:tcPr marL="54864" marR="45720" marT="22860" marB="22860">
                     <a:solidFill>
-                      <a:srgbClr val="1C2A3D"/>
+                      <a:srgbClr val="F1F5F9"/>
                     </a:solidFill>
                   </a:tcPr>
                 </a:tc>
@@ -8899,7 +8899,7 @@
                       <a:r>
                         <a:rPr sz="850" b="0">
                           <a:solidFill>
-                            <a:srgbClr val="ABB9C7"/>
+                            <a:srgbClr val="64748B"/>
                           </a:solidFill>
                           <a:latin typeface="Arial"/>
                         </a:rPr>
@@ -8909,7 +8909,7 @@
                   </a:txBody>
                   <a:tcPr marL="54864" marR="45720" marT="22860" marB="22860">
                     <a:solidFill>
-                      <a:srgbClr val="1C2A3D"/>
+                      <a:srgbClr val="F1F5F9"/>
                     </a:solidFill>
                   </a:tcPr>
                 </a:tc>
@@ -8922,7 +8922,7 @@
                       <a:r>
                         <a:rPr sz="850" b="0">
                           <a:solidFill>
-                            <a:srgbClr val="ABB9C7"/>
+                            <a:srgbClr val="64748B"/>
                           </a:solidFill>
                           <a:latin typeface="Arial"/>
                         </a:rPr>
@@ -8932,7 +8932,7 @@
                   </a:txBody>
                   <a:tcPr marL="54864" marR="45720" marT="22860" marB="22860">
                     <a:solidFill>
-                      <a:srgbClr val="1C2A3D"/>
+                      <a:srgbClr val="F1F5F9"/>
                     </a:solidFill>
                   </a:tcPr>
                 </a:tc>
@@ -8945,7 +8945,7 @@
                       <a:r>
                         <a:rPr sz="850" b="0">
                           <a:solidFill>
-                            <a:srgbClr val="ABB9C7"/>
+                            <a:srgbClr val="64748B"/>
                           </a:solidFill>
                           <a:latin typeface="Arial"/>
                         </a:rPr>
@@ -8955,7 +8955,7 @@
                   </a:txBody>
                   <a:tcPr marL="54864" marR="45720" marT="22860" marB="22860">
                     <a:solidFill>
-                      <a:srgbClr val="1C2A3D"/>
+                      <a:srgbClr val="F1F5F9"/>
                     </a:solidFill>
                   </a:tcPr>
                 </a:tc>
@@ -8970,7 +8970,7 @@
                       <a:r>
                         <a:rPr sz="850" b="0">
                           <a:solidFill>
-                            <a:srgbClr val="ABB9C7"/>
+                            <a:srgbClr val="64748B"/>
                           </a:solidFill>
                           <a:latin typeface="Arial"/>
                         </a:rPr>
@@ -8980,7 +8980,7 @@
                   </a:txBody>
                   <a:tcPr marL="54864" marR="45720" marT="22860" marB="22860">
                     <a:solidFill>
-                      <a:srgbClr val="1C2A3D"/>
+                      <a:srgbClr val="F1F5F9"/>
                     </a:solidFill>
                   </a:tcPr>
                 </a:tc>
@@ -8993,7 +8993,7 @@
                       <a:r>
                         <a:rPr sz="850" b="0">
                           <a:solidFill>
-                            <a:srgbClr val="ABB9C7"/>
+                            <a:srgbClr val="64748B"/>
                           </a:solidFill>
                           <a:latin typeface="Arial"/>
                         </a:rPr>
@@ -9003,7 +9003,7 @@
                   </a:txBody>
                   <a:tcPr marL="54864" marR="45720" marT="22860" marB="22860">
                     <a:solidFill>
-                      <a:srgbClr val="1C2A3D"/>
+                      <a:srgbClr val="F1F5F9"/>
                     </a:solidFill>
                   </a:tcPr>
                 </a:tc>
@@ -9016,7 +9016,7 @@
                       <a:r>
                         <a:rPr sz="850" b="0">
                           <a:solidFill>
-                            <a:srgbClr val="ABB9C7"/>
+                            <a:srgbClr val="64748B"/>
                           </a:solidFill>
                           <a:latin typeface="Arial"/>
                         </a:rPr>
@@ -9026,7 +9026,7 @@
                   </a:txBody>
                   <a:tcPr marL="54864" marR="45720" marT="22860" marB="22860">
                     <a:solidFill>
-                      <a:srgbClr val="1C2A3D"/>
+                      <a:srgbClr val="F1F5F9"/>
                     </a:solidFill>
                   </a:tcPr>
                 </a:tc>
@@ -9039,7 +9039,7 @@
                       <a:r>
                         <a:rPr sz="850" b="0">
                           <a:solidFill>
-                            <a:srgbClr val="ABB9C7"/>
+                            <a:srgbClr val="64748B"/>
                           </a:solidFill>
                           <a:latin typeface="Arial"/>
                         </a:rPr>
@@ -9049,7 +9049,7 @@
                   </a:txBody>
                   <a:tcPr marL="54864" marR="45720" marT="22860" marB="22860">
                     <a:solidFill>
-                      <a:srgbClr val="1C2A3D"/>
+                      <a:srgbClr val="F1F5F9"/>
                     </a:solidFill>
                   </a:tcPr>
                 </a:tc>
@@ -9062,7 +9062,7 @@
                       <a:r>
                         <a:rPr sz="850" b="0">
                           <a:solidFill>
-                            <a:srgbClr val="ABB9C7"/>
+                            <a:srgbClr val="64748B"/>
                           </a:solidFill>
                           <a:latin typeface="Arial"/>
                         </a:rPr>
@@ -9072,7 +9072,7 @@
                   </a:txBody>
                   <a:tcPr marL="54864" marR="45720" marT="22860" marB="22860">
                     <a:solidFill>
-                      <a:srgbClr val="1C2A3D"/>
+                      <a:srgbClr val="F1F5F9"/>
                     </a:solidFill>
                   </a:tcPr>
                 </a:tc>
@@ -9085,7 +9085,7 @@
                       <a:r>
                         <a:rPr sz="850" b="0">
                           <a:solidFill>
-                            <a:srgbClr val="ABB9C7"/>
+                            <a:srgbClr val="64748B"/>
                           </a:solidFill>
                           <a:latin typeface="Arial"/>
                         </a:rPr>
@@ -9095,7 +9095,7 @@
                   </a:txBody>
                   <a:tcPr marL="54864" marR="45720" marT="22860" marB="22860">
                     <a:solidFill>
-                      <a:srgbClr val="1C2A3D"/>
+                      <a:srgbClr val="F1F5F9"/>
                     </a:solidFill>
                   </a:tcPr>
                 </a:tc>
@@ -9108,7 +9108,7 @@
                       <a:r>
                         <a:rPr sz="850" b="0">
                           <a:solidFill>
-                            <a:srgbClr val="ABB9C7"/>
+                            <a:srgbClr val="64748B"/>
                           </a:solidFill>
                           <a:latin typeface="Arial"/>
                         </a:rPr>
@@ -9118,7 +9118,7 @@
                   </a:txBody>
                   <a:tcPr marL="54864" marR="45720" marT="22860" marB="22860">
                     <a:solidFill>
-                      <a:srgbClr val="1C2A3D"/>
+                      <a:srgbClr val="F1F5F9"/>
                     </a:solidFill>
                   </a:tcPr>
                 </a:tc>
@@ -9131,7 +9131,7 @@
                       <a:r>
                         <a:rPr sz="850" b="0">
                           <a:solidFill>
-                            <a:srgbClr val="ABB9C7"/>
+                            <a:srgbClr val="64748B"/>
                           </a:solidFill>
                           <a:latin typeface="Arial"/>
                         </a:rPr>
@@ -9141,7 +9141,7 @@
                   </a:txBody>
                   <a:tcPr marL="54864" marR="45720" marT="22860" marB="22860">
                     <a:solidFill>
-                      <a:srgbClr val="1C2A3D"/>
+                      <a:srgbClr val="F1F5F9"/>
                     </a:solidFill>
                   </a:tcPr>
                 </a:tc>
@@ -9156,7 +9156,7 @@
                       <a:r>
                         <a:rPr sz="850" b="0">
                           <a:solidFill>
-                            <a:srgbClr val="ABB9C7"/>
+                            <a:srgbClr val="64748B"/>
                           </a:solidFill>
                           <a:latin typeface="Arial"/>
                         </a:rPr>
@@ -9166,7 +9166,7 @@
                   </a:txBody>
                   <a:tcPr marL="54864" marR="45720" marT="22860" marB="22860">
                     <a:solidFill>
-                      <a:srgbClr val="1C2A3D"/>
+                      <a:srgbClr val="F1F5F9"/>
                     </a:solidFill>
                   </a:tcPr>
                 </a:tc>
@@ -9179,7 +9179,7 @@
                       <a:r>
                         <a:rPr sz="850" b="0">
                           <a:solidFill>
-                            <a:srgbClr val="ABB9C7"/>
+                            <a:srgbClr val="64748B"/>
                           </a:solidFill>
                           <a:latin typeface="Arial"/>
                         </a:rPr>
@@ -9189,7 +9189,7 @@
                   </a:txBody>
                   <a:tcPr marL="54864" marR="45720" marT="22860" marB="22860">
                     <a:solidFill>
-                      <a:srgbClr val="1C2A3D"/>
+                      <a:srgbClr val="F1F5F9"/>
                     </a:solidFill>
                   </a:tcPr>
                 </a:tc>
@@ -9202,7 +9202,7 @@
                       <a:r>
                         <a:rPr sz="850" b="0">
                           <a:solidFill>
-                            <a:srgbClr val="ABB9C7"/>
+                            <a:srgbClr val="64748B"/>
                           </a:solidFill>
                           <a:latin typeface="Arial"/>
                         </a:rPr>
@@ -9212,7 +9212,7 @@
                   </a:txBody>
                   <a:tcPr marL="54864" marR="45720" marT="22860" marB="22860">
                     <a:solidFill>
-                      <a:srgbClr val="1C2A3D"/>
+                      <a:srgbClr val="F1F5F9"/>
                     </a:solidFill>
                   </a:tcPr>
                 </a:tc>
@@ -9225,7 +9225,7 @@
                       <a:r>
                         <a:rPr sz="850" b="0">
                           <a:solidFill>
-                            <a:srgbClr val="ABB9C7"/>
+                            <a:srgbClr val="64748B"/>
                           </a:solidFill>
                           <a:latin typeface="Arial"/>
                         </a:rPr>
@@ -9235,7 +9235,7 @@
                   </a:txBody>
                   <a:tcPr marL="54864" marR="45720" marT="22860" marB="22860">
                     <a:solidFill>
-                      <a:srgbClr val="1C2A3D"/>
+                      <a:srgbClr val="F1F5F9"/>
                     </a:solidFill>
                   </a:tcPr>
                 </a:tc>
@@ -9248,7 +9248,7 @@
                       <a:r>
                         <a:rPr sz="850" b="0">
                           <a:solidFill>
-                            <a:srgbClr val="ABB9C7"/>
+                            <a:srgbClr val="64748B"/>
                           </a:solidFill>
                           <a:latin typeface="Arial"/>
                         </a:rPr>
@@ -9258,7 +9258,7 @@
                   </a:txBody>
                   <a:tcPr marL="54864" marR="45720" marT="22860" marB="22860">
                     <a:solidFill>
-                      <a:srgbClr val="1C2A3D"/>
+                      <a:srgbClr val="F1F5F9"/>
                     </a:solidFill>
                   </a:tcPr>
                 </a:tc>
@@ -9271,7 +9271,7 @@
                       <a:r>
                         <a:rPr sz="850" b="0">
                           <a:solidFill>
-                            <a:srgbClr val="ABB9C7"/>
+                            <a:srgbClr val="64748B"/>
                           </a:solidFill>
                           <a:latin typeface="Arial"/>
                         </a:rPr>
@@ -9281,7 +9281,7 @@
                   </a:txBody>
                   <a:tcPr marL="54864" marR="45720" marT="22860" marB="22860">
                     <a:solidFill>
-                      <a:srgbClr val="1C2A3D"/>
+                      <a:srgbClr val="F1F5F9"/>
                     </a:solidFill>
                   </a:tcPr>
                 </a:tc>
@@ -9294,7 +9294,7 @@
                       <a:r>
                         <a:rPr sz="850" b="0">
                           <a:solidFill>
-                            <a:srgbClr val="ABB9C7"/>
+                            <a:srgbClr val="64748B"/>
                           </a:solidFill>
                           <a:latin typeface="Arial"/>
                         </a:rPr>
@@ -9304,7 +9304,7 @@
                   </a:txBody>
                   <a:tcPr marL="54864" marR="45720" marT="22860" marB="22860">
                     <a:solidFill>
-                      <a:srgbClr val="1C2A3D"/>
+                      <a:srgbClr val="F1F5F9"/>
                     </a:solidFill>
                   </a:tcPr>
                 </a:tc>
@@ -9317,7 +9317,7 @@
                       <a:r>
                         <a:rPr sz="850" b="0">
                           <a:solidFill>
-                            <a:srgbClr val="ABB9C7"/>
+                            <a:srgbClr val="64748B"/>
                           </a:solidFill>
                           <a:latin typeface="Arial"/>
                         </a:rPr>
@@ -9327,7 +9327,7 @@
                   </a:txBody>
                   <a:tcPr marL="54864" marR="45720" marT="22860" marB="22860">
                     <a:solidFill>
-                      <a:srgbClr val="1C2A3D"/>
+                      <a:srgbClr val="F1F5F9"/>
                     </a:solidFill>
                   </a:tcPr>
                 </a:tc>
@@ -9342,7 +9342,7 @@
                       <a:r>
                         <a:rPr sz="850" b="0">
                           <a:solidFill>
-                            <a:srgbClr val="ABB9C7"/>
+                            <a:srgbClr val="64748B"/>
                           </a:solidFill>
                           <a:latin typeface="Arial"/>
                         </a:rPr>
@@ -9352,7 +9352,7 @@
                   </a:txBody>
                   <a:tcPr marL="54864" marR="45720" marT="22860" marB="22860">
                     <a:solidFill>
-                      <a:srgbClr val="1C2A3D"/>
+                      <a:srgbClr val="F1F5F9"/>
                     </a:solidFill>
                   </a:tcPr>
                 </a:tc>
@@ -9365,7 +9365,7 @@
                       <a:r>
                         <a:rPr sz="850" b="0">
                           <a:solidFill>
-                            <a:srgbClr val="ABB9C7"/>
+                            <a:srgbClr val="64748B"/>
                           </a:solidFill>
                           <a:latin typeface="Arial"/>
                         </a:rPr>
@@ -9375,7 +9375,7 @@
                   </a:txBody>
                   <a:tcPr marL="54864" marR="45720" marT="22860" marB="22860">
                     <a:solidFill>
-                      <a:srgbClr val="1C2A3D"/>
+                      <a:srgbClr val="F1F5F9"/>
                     </a:solidFill>
                   </a:tcPr>
                 </a:tc>
@@ -9388,7 +9388,7 @@
                       <a:r>
                         <a:rPr sz="850" b="0">
                           <a:solidFill>
-                            <a:srgbClr val="ABB9C7"/>
+                            <a:srgbClr val="64748B"/>
                           </a:solidFill>
                           <a:latin typeface="Arial"/>
                         </a:rPr>
@@ -9398,7 +9398,7 @@
                   </a:txBody>
                   <a:tcPr marL="54864" marR="45720" marT="22860" marB="22860">
                     <a:solidFill>
-                      <a:srgbClr val="1C2A3D"/>
+                      <a:srgbClr val="F1F5F9"/>
                     </a:solidFill>
                   </a:tcPr>
                 </a:tc>
@@ -9411,7 +9411,7 @@
                       <a:r>
                         <a:rPr sz="850" b="0">
                           <a:solidFill>
-                            <a:srgbClr val="ABB9C7"/>
+                            <a:srgbClr val="64748B"/>
                           </a:solidFill>
                           <a:latin typeface="Arial"/>
                         </a:rPr>
@@ -9421,7 +9421,7 @@
                   </a:txBody>
                   <a:tcPr marL="54864" marR="45720" marT="22860" marB="22860">
                     <a:solidFill>
-                      <a:srgbClr val="1C2A3D"/>
+                      <a:srgbClr val="F1F5F9"/>
                     </a:solidFill>
                   </a:tcPr>
                 </a:tc>
@@ -9434,7 +9434,7 @@
                       <a:r>
                         <a:rPr sz="850" b="0">
                           <a:solidFill>
-                            <a:srgbClr val="ABB9C7"/>
+                            <a:srgbClr val="64748B"/>
                           </a:solidFill>
                           <a:latin typeface="Arial"/>
                         </a:rPr>
@@ -9444,7 +9444,7 @@
                   </a:txBody>
                   <a:tcPr marL="54864" marR="45720" marT="22860" marB="22860">
                     <a:solidFill>
-                      <a:srgbClr val="1C2A3D"/>
+                      <a:srgbClr val="F1F5F9"/>
                     </a:solidFill>
                   </a:tcPr>
                 </a:tc>
@@ -9457,7 +9457,7 @@
                       <a:r>
                         <a:rPr sz="850" b="0">
                           <a:solidFill>
-                            <a:srgbClr val="ABB9C7"/>
+                            <a:srgbClr val="64748B"/>
                           </a:solidFill>
                           <a:latin typeface="Arial"/>
                         </a:rPr>
@@ -9467,7 +9467,7 @@
                   </a:txBody>
                   <a:tcPr marL="54864" marR="45720" marT="22860" marB="22860">
                     <a:solidFill>
-                      <a:srgbClr val="1C2A3D"/>
+                      <a:srgbClr val="F1F5F9"/>
                     </a:solidFill>
                   </a:tcPr>
                 </a:tc>
@@ -9480,7 +9480,7 @@
                       <a:r>
                         <a:rPr sz="850" b="0">
                           <a:solidFill>
-                            <a:srgbClr val="ABB9C7"/>
+                            <a:srgbClr val="64748B"/>
                           </a:solidFill>
                           <a:latin typeface="Arial"/>
                         </a:rPr>
@@ -9490,7 +9490,7 @@
                   </a:txBody>
                   <a:tcPr marL="54864" marR="45720" marT="22860" marB="22860">
                     <a:solidFill>
-                      <a:srgbClr val="1C2A3D"/>
+                      <a:srgbClr val="F1F5F9"/>
                     </a:solidFill>
                   </a:tcPr>
                 </a:tc>
@@ -9503,7 +9503,7 @@
                       <a:r>
                         <a:rPr sz="850" b="0">
                           <a:solidFill>
-                            <a:srgbClr val="ABB9C7"/>
+                            <a:srgbClr val="64748B"/>
                           </a:solidFill>
                           <a:latin typeface="Arial"/>
                         </a:rPr>
@@ -9513,7 +9513,7 @@
                   </a:txBody>
                   <a:tcPr marL="54864" marR="45720" marT="22860" marB="22860">
                     <a:solidFill>
-                      <a:srgbClr val="1C2A3D"/>
+                      <a:srgbClr val="F1F5F9"/>
                     </a:solidFill>
                   </a:tcPr>
                 </a:tc>
@@ -9528,7 +9528,7 @@
                       <a:r>
                         <a:rPr sz="850" b="0">
                           <a:solidFill>
-                            <a:srgbClr val="ABB9C7"/>
+                            <a:srgbClr val="64748B"/>
                           </a:solidFill>
                           <a:latin typeface="Arial"/>
                         </a:rPr>
@@ -9538,7 +9538,7 @@
                   </a:txBody>
                   <a:tcPr marL="54864" marR="45720" marT="22860" marB="22860">
                     <a:solidFill>
-                      <a:srgbClr val="1C2A3D"/>
+                      <a:srgbClr val="F1F5F9"/>
                     </a:solidFill>
                   </a:tcPr>
                 </a:tc>
@@ -9551,7 +9551,7 @@
                       <a:r>
                         <a:rPr sz="850" b="0">
                           <a:solidFill>
-                            <a:srgbClr val="ABB9C7"/>
+                            <a:srgbClr val="64748B"/>
                           </a:solidFill>
                           <a:latin typeface="Arial"/>
                         </a:rPr>
@@ -9561,7 +9561,7 @@
                   </a:txBody>
                   <a:tcPr marL="54864" marR="45720" marT="22860" marB="22860">
                     <a:solidFill>
-                      <a:srgbClr val="1C2A3D"/>
+                      <a:srgbClr val="F1F5F9"/>
                     </a:solidFill>
                   </a:tcPr>
                 </a:tc>
@@ -9574,7 +9574,7 @@
                       <a:r>
                         <a:rPr sz="850" b="0">
                           <a:solidFill>
-                            <a:srgbClr val="ABB9C7"/>
+                            <a:srgbClr val="64748B"/>
                           </a:solidFill>
                           <a:latin typeface="Arial"/>
                         </a:rPr>
@@ -9584,7 +9584,7 @@
                   </a:txBody>
                   <a:tcPr marL="54864" marR="45720" marT="22860" marB="22860">
                     <a:solidFill>
-                      <a:srgbClr val="1C2A3D"/>
+                      <a:srgbClr val="F1F5F9"/>
                     </a:solidFill>
                   </a:tcPr>
                 </a:tc>
@@ -9597,7 +9597,7 @@
                       <a:r>
                         <a:rPr sz="850" b="0">
                           <a:solidFill>
-                            <a:srgbClr val="ABB9C7"/>
+                            <a:srgbClr val="64748B"/>
                           </a:solidFill>
                           <a:latin typeface="Arial"/>
                         </a:rPr>
@@ -9607,7 +9607,7 @@
                   </a:txBody>
                   <a:tcPr marL="54864" marR="45720" marT="22860" marB="22860">
                     <a:solidFill>
-                      <a:srgbClr val="1C2A3D"/>
+                      <a:srgbClr val="F1F5F9"/>
                     </a:solidFill>
                   </a:tcPr>
                 </a:tc>
@@ -9620,7 +9620,7 @@
                       <a:r>
                         <a:rPr sz="850" b="0">
                           <a:solidFill>
-                            <a:srgbClr val="ABB9C7"/>
+                            <a:srgbClr val="64748B"/>
                           </a:solidFill>
                           <a:latin typeface="Arial"/>
                         </a:rPr>
@@ -9630,7 +9630,7 @@
                   </a:txBody>
                   <a:tcPr marL="54864" marR="45720" marT="22860" marB="22860">
                     <a:solidFill>
-                      <a:srgbClr val="1C2A3D"/>
+                      <a:srgbClr val="F1F5F9"/>
                     </a:solidFill>
                   </a:tcPr>
                 </a:tc>
@@ -9643,7 +9643,7 @@
                       <a:r>
                         <a:rPr sz="850" b="0">
                           <a:solidFill>
-                            <a:srgbClr val="ABB9C7"/>
+                            <a:srgbClr val="64748B"/>
                           </a:solidFill>
                           <a:latin typeface="Arial"/>
                         </a:rPr>
@@ -9653,7 +9653,7 @@
                   </a:txBody>
                   <a:tcPr marL="54864" marR="45720" marT="22860" marB="22860">
                     <a:solidFill>
-                      <a:srgbClr val="1C2A3D"/>
+                      <a:srgbClr val="F1F5F9"/>
                     </a:solidFill>
                   </a:tcPr>
                 </a:tc>
@@ -9666,7 +9666,7 @@
                       <a:r>
                         <a:rPr sz="850" b="0">
                           <a:solidFill>
-                            <a:srgbClr val="ABB9C7"/>
+                            <a:srgbClr val="64748B"/>
                           </a:solidFill>
                           <a:latin typeface="Arial"/>
                         </a:rPr>
@@ -9676,7 +9676,7 @@
                   </a:txBody>
                   <a:tcPr marL="54864" marR="45720" marT="22860" marB="22860">
                     <a:solidFill>
-                      <a:srgbClr val="1C2A3D"/>
+                      <a:srgbClr val="F1F5F9"/>
                     </a:solidFill>
                   </a:tcPr>
                 </a:tc>
@@ -9689,7 +9689,7 @@
                       <a:r>
                         <a:rPr sz="850" b="0">
                           <a:solidFill>
-                            <a:srgbClr val="ABB9C7"/>
+                            <a:srgbClr val="64748B"/>
                           </a:solidFill>
                           <a:latin typeface="Arial"/>
                         </a:rPr>
@@ -9699,7 +9699,7 @@
                   </a:txBody>
                   <a:tcPr marL="54864" marR="45720" marT="22860" marB="22860">
                     <a:solidFill>
-                      <a:srgbClr val="1C2A3D"/>
+                      <a:srgbClr val="F1F5F9"/>
                     </a:solidFill>
                   </a:tcPr>
                 </a:tc>
@@ -9738,7 +9738,7 @@
             <a:r>
               <a:rPr sz="1000" b="0">
                 <a:solidFill>
-                  <a:srgbClr val="ABB9C7"/>
+                  <a:srgbClr val="64748B"/>
                 </a:solidFill>
                 <a:latin typeface="Arial"/>
               </a:rPr>
@@ -9780,7 +9780,7 @@
             <a:avLst/>
           </a:prstGeom>
           <a:solidFill>
-            <a:srgbClr val="121B2A"/>
+            <a:srgbClr val="FFFFFF"/>
           </a:solidFill>
           <a:ln>
             <a:noFill/>
@@ -9838,7 +9838,7 @@
             <a:r>
               <a:rPr sz="1000" b="1">
                 <a:solidFill>
-                  <a:srgbClr val="4AB8A7"/>
+                  <a:srgbClr val="2E6F9E"/>
                 </a:solidFill>
                 <a:latin typeface="Arial"/>
               </a:rPr>
@@ -9877,7 +9877,7 @@
             <a:r>
               <a:rPr sz="2600" b="1">
                 <a:solidFill>
-                  <a:srgbClr val="EBF0F6"/>
+                  <a:srgbClr val="263238"/>
                 </a:solidFill>
                 <a:latin typeface="Arial"/>
               </a:rPr>
@@ -9901,7 +9901,7 @@
             <a:avLst/>
           </a:prstGeom>
           <a:solidFill>
-            <a:srgbClr val="1C2A3D"/>
+            <a:srgbClr val="F1F5F9"/>
           </a:solidFill>
           <a:ln>
             <a:noFill/>
@@ -9959,7 +9959,7 @@
             <a:r>
               <a:rPr sz="900" b="0">
                 <a:solidFill>
-                  <a:srgbClr val="ABB9C7"/>
+                  <a:srgbClr val="64748B"/>
                 </a:solidFill>
                 <a:latin typeface="Arial"/>
               </a:rPr>
@@ -9998,7 +9998,7 @@
             <a:r>
               <a:rPr sz="1000" b="0">
                 <a:solidFill>
-                  <a:srgbClr val="ABB9C7"/>
+                  <a:srgbClr val="64748B"/>
                 </a:solidFill>
                 <a:latin typeface="Arial"/>
               </a:rPr>
@@ -10046,7 +10046,7 @@
             <a:avLst/>
           </a:prstGeom>
           <a:solidFill>
-            <a:srgbClr val="1C2A3D"/>
+            <a:srgbClr val="F1F5F9"/>
           </a:solidFill>
           <a:ln>
             <a:noFill/>
@@ -10104,7 +10104,7 @@
             <a:r>
               <a:rPr sz="2500" b="1">
                 <a:solidFill>
-                  <a:srgbClr val="5A89B2"/>
+                  <a:srgbClr val="2E6F9E"/>
                 </a:solidFill>
                 <a:latin typeface="Arial"/>
               </a:rPr>
@@ -10143,7 +10143,7 @@
             <a:r>
               <a:rPr sz="1200" b="1">
                 <a:solidFill>
-                  <a:srgbClr val="EBF0F6"/>
+                  <a:srgbClr val="263238"/>
                 </a:solidFill>
                 <a:latin typeface="Arial"/>
               </a:rPr>
@@ -10167,7 +10167,7 @@
             <a:avLst/>
           </a:prstGeom>
           <a:solidFill>
-            <a:srgbClr val="1C2A3D"/>
+            <a:srgbClr val="F1F5F9"/>
           </a:solidFill>
           <a:ln>
             <a:noFill/>
@@ -10225,7 +10225,7 @@
             <a:r>
               <a:rPr sz="2500" b="1">
                 <a:solidFill>
-                  <a:srgbClr val="E8874B"/>
+                  <a:srgbClr val="A8B4C0"/>
                 </a:solidFill>
                 <a:latin typeface="Arial"/>
               </a:rPr>
@@ -10264,7 +10264,7 @@
             <a:r>
               <a:rPr sz="1200" b="1">
                 <a:solidFill>
-                  <a:srgbClr val="EBF0F6"/>
+                  <a:srgbClr val="263238"/>
                 </a:solidFill>
                 <a:latin typeface="Arial"/>
               </a:rPr>
@@ -10288,7 +10288,7 @@
             <a:avLst/>
           </a:prstGeom>
           <a:solidFill>
-            <a:srgbClr val="1C2A3D"/>
+            <a:srgbClr val="F1F5F9"/>
           </a:solidFill>
           <a:ln>
             <a:noFill/>
@@ -10346,7 +10346,7 @@
             <a:r>
               <a:rPr sz="2500" b="1">
                 <a:solidFill>
-                  <a:srgbClr val="E8874B"/>
+                  <a:srgbClr val="A8B4C0"/>
                 </a:solidFill>
                 <a:latin typeface="Arial"/>
               </a:rPr>
@@ -10385,7 +10385,7 @@
             <a:r>
               <a:rPr sz="1200" b="1">
                 <a:solidFill>
-                  <a:srgbClr val="EBF0F6"/>
+                  <a:srgbClr val="263238"/>
                 </a:solidFill>
                 <a:latin typeface="Arial"/>
               </a:rPr>
@@ -10409,7 +10409,7 @@
             <a:avLst/>
           </a:prstGeom>
           <a:solidFill>
-            <a:srgbClr val="1C2A3D"/>
+            <a:srgbClr val="F1F5F9"/>
           </a:solidFill>
           <a:ln>
             <a:noFill/>
@@ -10467,7 +10467,7 @@
             <a:r>
               <a:rPr sz="2500" b="1">
                 <a:solidFill>
-                  <a:srgbClr val="4AB8A7"/>
+                  <a:srgbClr val="2E6F9E"/>
                 </a:solidFill>
                 <a:latin typeface="Arial"/>
               </a:rPr>
@@ -10506,7 +10506,7 @@
             <a:r>
               <a:rPr sz="1200" b="1">
                 <a:solidFill>
-                  <a:srgbClr val="EBF0F6"/>
+                  <a:srgbClr val="263238"/>
                 </a:solidFill>
                 <a:latin typeface="Arial"/>
               </a:rPr>
@@ -10545,7 +10545,7 @@
             <a:r>
               <a:rPr sz="1200" b="0">
                 <a:solidFill>
-                  <a:srgbClr val="ABB9C7"/>
+                  <a:srgbClr val="64748B"/>
                 </a:solidFill>
                 <a:latin typeface="Arial"/>
               </a:rPr>
@@ -10587,7 +10587,7 @@
             <a:avLst/>
           </a:prstGeom>
           <a:solidFill>
-            <a:srgbClr val="121B2A"/>
+            <a:srgbClr val="FFFFFF"/>
           </a:solidFill>
           <a:ln>
             <a:noFill/>
@@ -10645,7 +10645,7 @@
             <a:r>
               <a:rPr sz="1000" b="1">
                 <a:solidFill>
-                  <a:srgbClr val="4AB8A7"/>
+                  <a:srgbClr val="2E6F9E"/>
                 </a:solidFill>
                 <a:latin typeface="Arial"/>
               </a:rPr>
@@ -10684,7 +10684,7 @@
             <a:r>
               <a:rPr sz="2600" b="1">
                 <a:solidFill>
-                  <a:srgbClr val="EBF0F6"/>
+                  <a:srgbClr val="263238"/>
                 </a:solidFill>
                 <a:latin typeface="Arial"/>
               </a:rPr>
@@ -10708,7 +10708,7 @@
             <a:avLst/>
           </a:prstGeom>
           <a:solidFill>
-            <a:srgbClr val="1C2A3D"/>
+            <a:srgbClr val="F1F5F9"/>
           </a:solidFill>
           <a:ln>
             <a:noFill/>
@@ -10766,7 +10766,7 @@
             <a:r>
               <a:rPr sz="900" b="0">
                 <a:solidFill>
-                  <a:srgbClr val="ABB9C7"/>
+                  <a:srgbClr val="64748B"/>
                 </a:solidFill>
                 <a:latin typeface="Arial"/>
               </a:rPr>
@@ -10805,7 +10805,7 @@
             <a:r>
               <a:rPr sz="1000" b="0">
                 <a:solidFill>
-                  <a:srgbClr val="ABB9C7"/>
+                  <a:srgbClr val="64748B"/>
                 </a:solidFill>
                 <a:latin typeface="Arial"/>
               </a:rPr>
@@ -10829,7 +10829,7 @@
             <a:avLst/>
           </a:prstGeom>
           <a:solidFill>
-            <a:srgbClr val="1C2A3D"/>
+            <a:srgbClr val="F1F5F9"/>
           </a:solidFill>
           <a:ln>
             <a:noFill/>
@@ -10887,7 +10887,7 @@
             <a:r>
               <a:rPr sz="2500" b="1">
                 <a:solidFill>
-                  <a:srgbClr val="5A89B2"/>
+                  <a:srgbClr val="2E6F9E"/>
                 </a:solidFill>
                 <a:latin typeface="Arial"/>
               </a:rPr>
@@ -10926,7 +10926,7 @@
             <a:r>
               <a:rPr sz="1200" b="1">
                 <a:solidFill>
-                  <a:srgbClr val="EBF0F6"/>
+                  <a:srgbClr val="263238"/>
                 </a:solidFill>
                 <a:latin typeface="Arial"/>
               </a:rPr>
@@ -10950,7 +10950,7 @@
             <a:avLst/>
           </a:prstGeom>
           <a:solidFill>
-            <a:srgbClr val="1C2A3D"/>
+            <a:srgbClr val="F1F5F9"/>
           </a:solidFill>
           <a:ln>
             <a:noFill/>
@@ -11008,7 +11008,7 @@
             <a:r>
               <a:rPr sz="2500" b="1">
                 <a:solidFill>
-                  <a:srgbClr val="4AB8A7"/>
+                  <a:srgbClr val="2E6F9E"/>
                 </a:solidFill>
                 <a:latin typeface="Arial"/>
               </a:rPr>
@@ -11047,7 +11047,7 @@
             <a:r>
               <a:rPr sz="1200" b="1">
                 <a:solidFill>
-                  <a:srgbClr val="EBF0F6"/>
+                  <a:srgbClr val="263238"/>
                 </a:solidFill>
                 <a:latin typeface="Arial"/>
               </a:rPr>
@@ -11071,7 +11071,7 @@
             <a:avLst/>
           </a:prstGeom>
           <a:solidFill>
-            <a:srgbClr val="1C2A3D"/>
+            <a:srgbClr val="F1F5F9"/>
           </a:solidFill>
           <a:ln>
             <a:noFill/>
@@ -11129,7 +11129,7 @@
             <a:r>
               <a:rPr sz="2500" b="1">
                 <a:solidFill>
-                  <a:srgbClr val="E8874B"/>
+                  <a:srgbClr val="A8B4C0"/>
                 </a:solidFill>
                 <a:latin typeface="Arial"/>
               </a:rPr>
@@ -11168,7 +11168,7 @@
             <a:r>
               <a:rPr sz="1200" b="1">
                 <a:solidFill>
-                  <a:srgbClr val="EBF0F6"/>
+                  <a:srgbClr val="263238"/>
                 </a:solidFill>
                 <a:latin typeface="Arial"/>
               </a:rPr>
@@ -11192,7 +11192,7 @@
             <a:avLst/>
           </a:prstGeom>
           <a:solidFill>
-            <a:srgbClr val="E8874B"/>
+            <a:srgbClr val="A8B4C0"/>
           </a:solidFill>
           <a:ln>
             <a:noFill/>
@@ -11250,7 +11250,7 @@
             <a:r>
               <a:rPr sz="1400" b="0">
                 <a:solidFill>
-                  <a:srgbClr val="EBF0F6"/>
+                  <a:srgbClr val="263238"/>
                 </a:solidFill>
                 <a:latin typeface="Arial"/>
               </a:rPr>
@@ -11274,7 +11274,7 @@
             <a:avLst/>
           </a:prstGeom>
           <a:solidFill>
-            <a:srgbClr val="4AB8A7"/>
+            <a:srgbClr val="2E6F9E"/>
           </a:solidFill>
           <a:ln>
             <a:noFill/>
@@ -11332,7 +11332,7 @@
             <a:r>
               <a:rPr sz="1400" b="0">
                 <a:solidFill>
-                  <a:srgbClr val="EBF0F6"/>
+                  <a:srgbClr val="263238"/>
                 </a:solidFill>
                 <a:latin typeface="Arial"/>
               </a:rPr>
@@ -11356,7 +11356,7 @@
             <a:avLst/>
           </a:prstGeom>
           <a:solidFill>
-            <a:srgbClr val="4AB8A7"/>
+            <a:srgbClr val="2E6F9E"/>
           </a:solidFill>
           <a:ln>
             <a:noFill/>
@@ -11414,7 +11414,7 @@
             <a:r>
               <a:rPr sz="1400" b="0">
                 <a:solidFill>
-                  <a:srgbClr val="EBF0F6"/>
+                  <a:srgbClr val="263238"/>
                 </a:solidFill>
                 <a:latin typeface="Arial"/>
               </a:rPr>
@@ -11438,7 +11438,7 @@
             <a:avLst/>
           </a:prstGeom>
           <a:solidFill>
-            <a:srgbClr val="4AB8A7"/>
+            <a:srgbClr val="2E6F9E"/>
           </a:solidFill>
           <a:ln>
             <a:noFill/>
@@ -11496,7 +11496,7 @@
             <a:r>
               <a:rPr sz="1400" b="0">
                 <a:solidFill>
-                  <a:srgbClr val="EBF0F6"/>
+                  <a:srgbClr val="263238"/>
                 </a:solidFill>
                 <a:latin typeface="Arial"/>
               </a:rPr>
@@ -11538,7 +11538,7 @@
             <a:avLst/>
           </a:prstGeom>
           <a:solidFill>
-            <a:srgbClr val="121B2A"/>
+            <a:srgbClr val="FFFFFF"/>
           </a:solidFill>
           <a:ln>
             <a:noFill/>
@@ -11596,7 +11596,7 @@
             <a:r>
               <a:rPr sz="1000" b="1">
                 <a:solidFill>
-                  <a:srgbClr val="4AB8A7"/>
+                  <a:srgbClr val="2E6F9E"/>
                 </a:solidFill>
                 <a:latin typeface="Arial"/>
               </a:rPr>
@@ -11635,7 +11635,7 @@
             <a:r>
               <a:rPr sz="2600" b="1">
                 <a:solidFill>
-                  <a:srgbClr val="EBF0F6"/>
+                  <a:srgbClr val="263238"/>
                 </a:solidFill>
                 <a:latin typeface="Arial"/>
               </a:rPr>
@@ -11659,7 +11659,7 @@
             <a:avLst/>
           </a:prstGeom>
           <a:solidFill>
-            <a:srgbClr val="1C2A3D"/>
+            <a:srgbClr val="F1F5F9"/>
           </a:solidFill>
           <a:ln>
             <a:noFill/>
@@ -11717,7 +11717,7 @@
             <a:r>
               <a:rPr sz="900" b="0">
                 <a:solidFill>
-                  <a:srgbClr val="ABB9C7"/>
+                  <a:srgbClr val="64748B"/>
                 </a:solidFill>
                 <a:latin typeface="Arial"/>
               </a:rPr>
@@ -11756,7 +11756,7 @@
             <a:r>
               <a:rPr sz="1000" b="0">
                 <a:solidFill>
-                  <a:srgbClr val="ABB9C7"/>
+                  <a:srgbClr val="64748B"/>
                 </a:solidFill>
                 <a:latin typeface="Arial"/>
               </a:rPr>
@@ -11798,7 +11798,7 @@
                       <a:r>
                         <a:rPr sz="1400" b="1">
                           <a:solidFill>
-                            <a:srgbClr val="EBF0F6"/>
+                            <a:srgbClr val="263238"/>
                           </a:solidFill>
                           <a:latin typeface="Arial"/>
                         </a:rPr>
@@ -11808,7 +11808,7 @@
                   </a:txBody>
                   <a:tcPr marL="54864" marR="45720" marT="22860" marB="22860">
                     <a:solidFill>
-                      <a:srgbClr val="2A3E52"/>
+                      <a:srgbClr val="DCE8F1"/>
                     </a:solidFill>
                   </a:tcPr>
                 </a:tc>
@@ -11821,7 +11821,7 @@
                       <a:r>
                         <a:rPr sz="1400" b="1">
                           <a:solidFill>
-                            <a:srgbClr val="EBF0F6"/>
+                            <a:srgbClr val="263238"/>
                           </a:solidFill>
                           <a:latin typeface="Arial"/>
                         </a:rPr>
@@ -11831,7 +11831,7 @@
                   </a:txBody>
                   <a:tcPr marL="54864" marR="45720" marT="22860" marB="22860">
                     <a:solidFill>
-                      <a:srgbClr val="2A3E52"/>
+                      <a:srgbClr val="DCE8F1"/>
                     </a:solidFill>
                   </a:tcPr>
                 </a:tc>
@@ -11844,7 +11844,7 @@
                       <a:r>
                         <a:rPr sz="1400" b="1">
                           <a:solidFill>
-                            <a:srgbClr val="EBF0F6"/>
+                            <a:srgbClr val="263238"/>
                           </a:solidFill>
                           <a:latin typeface="Arial"/>
                         </a:rPr>
@@ -11854,7 +11854,7 @@
                   </a:txBody>
                   <a:tcPr marL="54864" marR="45720" marT="22860" marB="22860">
                     <a:solidFill>
-                      <a:srgbClr val="2A3E52"/>
+                      <a:srgbClr val="DCE8F1"/>
                     </a:solidFill>
                   </a:tcPr>
                 </a:tc>
@@ -11869,7 +11869,7 @@
                       <a:r>
                         <a:rPr sz="1400" b="0">
                           <a:solidFill>
-                            <a:srgbClr val="ABB9C7"/>
+                            <a:srgbClr val="64748B"/>
                           </a:solidFill>
                           <a:latin typeface="Arial"/>
                         </a:rPr>
@@ -11879,7 +11879,7 @@
                   </a:txBody>
                   <a:tcPr marL="54864" marR="45720" marT="22860" marB="22860">
                     <a:solidFill>
-                      <a:srgbClr val="1C2A3D"/>
+                      <a:srgbClr val="F1F5F9"/>
                     </a:solidFill>
                   </a:tcPr>
                 </a:tc>
@@ -11892,7 +11892,7 @@
                       <a:r>
                         <a:rPr sz="1400" b="0">
                           <a:solidFill>
-                            <a:srgbClr val="ABB9C7"/>
+                            <a:srgbClr val="64748B"/>
                           </a:solidFill>
                           <a:latin typeface="Arial"/>
                         </a:rPr>
@@ -11902,7 +11902,7 @@
                   </a:txBody>
                   <a:tcPr marL="54864" marR="45720" marT="22860" marB="22860">
                     <a:solidFill>
-                      <a:srgbClr val="1C2A3D"/>
+                      <a:srgbClr val="F1F5F9"/>
                     </a:solidFill>
                   </a:tcPr>
                 </a:tc>
@@ -11915,7 +11915,7 @@
                       <a:r>
                         <a:rPr sz="1400" b="0">
                           <a:solidFill>
-                            <a:srgbClr val="ABB9C7"/>
+                            <a:srgbClr val="64748B"/>
                           </a:solidFill>
                           <a:latin typeface="Arial"/>
                         </a:rPr>
@@ -11925,7 +11925,7 @@
                   </a:txBody>
                   <a:tcPr marL="54864" marR="45720" marT="22860" marB="22860">
                     <a:solidFill>
-                      <a:srgbClr val="1C2A3D"/>
+                      <a:srgbClr val="F1F5F9"/>
                     </a:solidFill>
                   </a:tcPr>
                 </a:tc>
@@ -11940,7 +11940,7 @@
                       <a:r>
                         <a:rPr sz="1400" b="0">
                           <a:solidFill>
-                            <a:srgbClr val="ABB9C7"/>
+                            <a:srgbClr val="64748B"/>
                           </a:solidFill>
                           <a:latin typeface="Arial"/>
                         </a:rPr>
@@ -11950,7 +11950,7 @@
                   </a:txBody>
                   <a:tcPr marL="54864" marR="45720" marT="22860" marB="22860">
                     <a:solidFill>
-                      <a:srgbClr val="1C2A3D"/>
+                      <a:srgbClr val="F1F5F9"/>
                     </a:solidFill>
                   </a:tcPr>
                 </a:tc>
@@ -11963,7 +11963,7 @@
                       <a:r>
                         <a:rPr sz="1400" b="0">
                           <a:solidFill>
-                            <a:srgbClr val="ABB9C7"/>
+                            <a:srgbClr val="64748B"/>
                           </a:solidFill>
                           <a:latin typeface="Arial"/>
                         </a:rPr>
@@ -11973,7 +11973,7 @@
                   </a:txBody>
                   <a:tcPr marL="54864" marR="45720" marT="22860" marB="22860">
                     <a:solidFill>
-                      <a:srgbClr val="1C2A3D"/>
+                      <a:srgbClr val="F1F5F9"/>
                     </a:solidFill>
                   </a:tcPr>
                 </a:tc>
@@ -11986,7 +11986,7 @@
                       <a:r>
                         <a:rPr sz="1400" b="0">
                           <a:solidFill>
-                            <a:srgbClr val="ABB9C7"/>
+                            <a:srgbClr val="64748B"/>
                           </a:solidFill>
                           <a:latin typeface="Arial"/>
                         </a:rPr>
@@ -11996,7 +11996,7 @@
                   </a:txBody>
                   <a:tcPr marL="54864" marR="45720" marT="22860" marB="22860">
                     <a:solidFill>
-                      <a:srgbClr val="1C2A3D"/>
+                      <a:srgbClr val="F1F5F9"/>
                     </a:solidFill>
                   </a:tcPr>
                 </a:tc>
@@ -12011,7 +12011,7 @@
                       <a:r>
                         <a:rPr sz="1400" b="0">
                           <a:solidFill>
-                            <a:srgbClr val="ABB9C7"/>
+                            <a:srgbClr val="64748B"/>
                           </a:solidFill>
                           <a:latin typeface="Arial"/>
                         </a:rPr>
@@ -12021,7 +12021,7 @@
                   </a:txBody>
                   <a:tcPr marL="54864" marR="45720" marT="22860" marB="22860">
                     <a:solidFill>
-                      <a:srgbClr val="1C2A3D"/>
+                      <a:srgbClr val="F1F5F9"/>
                     </a:solidFill>
                   </a:tcPr>
                 </a:tc>
@@ -12034,7 +12034,7 @@
                       <a:r>
                         <a:rPr sz="1400" b="0">
                           <a:solidFill>
-                            <a:srgbClr val="ABB9C7"/>
+                            <a:srgbClr val="64748B"/>
                           </a:solidFill>
                           <a:latin typeface="Arial"/>
                         </a:rPr>
@@ -12044,7 +12044,7 @@
                   </a:txBody>
                   <a:tcPr marL="54864" marR="45720" marT="22860" marB="22860">
                     <a:solidFill>
-                      <a:srgbClr val="1C2A3D"/>
+                      <a:srgbClr val="F1F5F9"/>
                     </a:solidFill>
                   </a:tcPr>
                 </a:tc>
@@ -12057,7 +12057,7 @@
                       <a:r>
                         <a:rPr sz="1400" b="0">
                           <a:solidFill>
-                            <a:srgbClr val="ABB9C7"/>
+                            <a:srgbClr val="64748B"/>
                           </a:solidFill>
                           <a:latin typeface="Arial"/>
                         </a:rPr>
@@ -12067,7 +12067,7 @@
                   </a:txBody>
                   <a:tcPr marL="54864" marR="45720" marT="22860" marB="22860">
                     <a:solidFill>
-                      <a:srgbClr val="1C2A3D"/>
+                      <a:srgbClr val="F1F5F9"/>
                     </a:solidFill>
                   </a:tcPr>
                 </a:tc>
@@ -12082,7 +12082,7 @@
                       <a:r>
                         <a:rPr sz="1400" b="0">
                           <a:solidFill>
-                            <a:srgbClr val="ABB9C7"/>
+                            <a:srgbClr val="64748B"/>
                           </a:solidFill>
                           <a:latin typeface="Arial"/>
                         </a:rPr>
@@ -12092,7 +12092,7 @@
                   </a:txBody>
                   <a:tcPr marL="54864" marR="45720" marT="22860" marB="22860">
                     <a:solidFill>
-                      <a:srgbClr val="1C2A3D"/>
+                      <a:srgbClr val="F1F5F9"/>
                     </a:solidFill>
                   </a:tcPr>
                 </a:tc>
@@ -12105,7 +12105,7 @@
                       <a:r>
                         <a:rPr sz="1400" b="0">
                           <a:solidFill>
-                            <a:srgbClr val="ABB9C7"/>
+                            <a:srgbClr val="64748B"/>
                           </a:solidFill>
                           <a:latin typeface="Arial"/>
                         </a:rPr>
@@ -12115,7 +12115,7 @@
                   </a:txBody>
                   <a:tcPr marL="54864" marR="45720" marT="22860" marB="22860">
                     <a:solidFill>
-                      <a:srgbClr val="1C2A3D"/>
+                      <a:srgbClr val="F1F5F9"/>
                     </a:solidFill>
                   </a:tcPr>
                 </a:tc>
@@ -12128,7 +12128,7 @@
                       <a:r>
                         <a:rPr sz="1400" b="0">
                           <a:solidFill>
-                            <a:srgbClr val="ABB9C7"/>
+                            <a:srgbClr val="64748B"/>
                           </a:solidFill>
                           <a:latin typeface="Arial"/>
                         </a:rPr>
@@ -12138,7 +12138,7 @@
                   </a:txBody>
                   <a:tcPr marL="54864" marR="45720" marT="22860" marB="22860">
                     <a:solidFill>
-                      <a:srgbClr val="1C2A3D"/>
+                      <a:srgbClr val="F1F5F9"/>
                     </a:solidFill>
                   </a:tcPr>
                 </a:tc>
@@ -12177,7 +12177,7 @@
             <a:r>
               <a:rPr sz="1700" b="1">
                 <a:solidFill>
-                  <a:srgbClr val="4AB8A7"/>
+                  <a:srgbClr val="2E6F9E"/>
                 </a:solidFill>
                 <a:latin typeface="Arial"/>
               </a:rPr>
@@ -12201,7 +12201,7 @@
             <a:avLst/>
           </a:prstGeom>
           <a:solidFill>
-            <a:srgbClr val="E8874B"/>
+            <a:srgbClr val="A8B4C0"/>
           </a:solidFill>
           <a:ln>
             <a:noFill/>
@@ -12259,7 +12259,7 @@
             <a:r>
               <a:rPr sz="1400" b="0">
                 <a:solidFill>
-                  <a:srgbClr val="EBF0F6"/>
+                  <a:srgbClr val="263238"/>
                 </a:solidFill>
                 <a:latin typeface="Arial"/>
               </a:rPr>
@@ -12283,7 +12283,7 @@
             <a:avLst/>
           </a:prstGeom>
           <a:solidFill>
-            <a:srgbClr val="4AB8A7"/>
+            <a:srgbClr val="2E6F9E"/>
           </a:solidFill>
           <a:ln>
             <a:noFill/>
@@ -12341,7 +12341,7 @@
             <a:r>
               <a:rPr sz="1400" b="0">
                 <a:solidFill>
-                  <a:srgbClr val="EBF0F6"/>
+                  <a:srgbClr val="263238"/>
                 </a:solidFill>
                 <a:latin typeface="Arial"/>
               </a:rPr>
@@ -12365,7 +12365,7 @@
             <a:avLst/>
           </a:prstGeom>
           <a:solidFill>
-            <a:srgbClr val="4AB8A7"/>
+            <a:srgbClr val="2E6F9E"/>
           </a:solidFill>
           <a:ln>
             <a:noFill/>
@@ -12423,7 +12423,7 @@
             <a:r>
               <a:rPr sz="1400" b="0">
                 <a:solidFill>
-                  <a:srgbClr val="EBF0F6"/>
+                  <a:srgbClr val="263238"/>
                 </a:solidFill>
                 <a:latin typeface="Arial"/>
               </a:rPr>
@@ -12447,7 +12447,7 @@
             <a:avLst/>
           </a:prstGeom>
           <a:solidFill>
-            <a:srgbClr val="4AB8A7"/>
+            <a:srgbClr val="2E6F9E"/>
           </a:solidFill>
           <a:ln>
             <a:noFill/>
@@ -12505,7 +12505,7 @@
             <a:r>
               <a:rPr sz="1400" b="0">
                 <a:solidFill>
-                  <a:srgbClr val="EBF0F6"/>
+                  <a:srgbClr val="263238"/>
                 </a:solidFill>
                 <a:latin typeface="Arial"/>
               </a:rPr>
@@ -12547,7 +12547,7 @@
             <a:avLst/>
           </a:prstGeom>
           <a:solidFill>
-            <a:srgbClr val="121B2A"/>
+            <a:srgbClr val="FFFFFF"/>
           </a:solidFill>
           <a:ln>
             <a:noFill/>
@@ -12605,7 +12605,7 @@
             <a:r>
               <a:rPr sz="1000" b="1">
                 <a:solidFill>
-                  <a:srgbClr val="4AB8A7"/>
+                  <a:srgbClr val="2E6F9E"/>
                 </a:solidFill>
                 <a:latin typeface="Arial"/>
               </a:rPr>
@@ -12644,7 +12644,7 @@
             <a:r>
               <a:rPr sz="2600" b="1">
                 <a:solidFill>
-                  <a:srgbClr val="EBF0F6"/>
+                  <a:srgbClr val="263238"/>
                 </a:solidFill>
                 <a:latin typeface="Arial"/>
               </a:rPr>
@@ -12668,7 +12668,7 @@
             <a:avLst/>
           </a:prstGeom>
           <a:solidFill>
-            <a:srgbClr val="1C2A3D"/>
+            <a:srgbClr val="F1F5F9"/>
           </a:solidFill>
           <a:ln>
             <a:noFill/>
@@ -12726,7 +12726,7 @@
             <a:r>
               <a:rPr sz="900" b="0">
                 <a:solidFill>
-                  <a:srgbClr val="ABB9C7"/>
+                  <a:srgbClr val="64748B"/>
                 </a:solidFill>
                 <a:latin typeface="Arial"/>
               </a:rPr>
@@ -12765,7 +12765,7 @@
             <a:r>
               <a:rPr sz="1000" b="0">
                 <a:solidFill>
-                  <a:srgbClr val="ABB9C7"/>
+                  <a:srgbClr val="64748B"/>
                 </a:solidFill>
                 <a:latin typeface="Arial"/>
               </a:rPr>
@@ -12789,7 +12789,7 @@
             <a:avLst/>
           </a:prstGeom>
           <a:solidFill>
-            <a:srgbClr val="1C2A3D"/>
+            <a:srgbClr val="F1F5F9"/>
           </a:solidFill>
           <a:ln>
             <a:noFill/>
@@ -12847,7 +12847,7 @@
             <a:r>
               <a:rPr sz="2500" b="1">
                 <a:solidFill>
-                  <a:srgbClr val="4AB8A7"/>
+                  <a:srgbClr val="2E6F9E"/>
                 </a:solidFill>
                 <a:latin typeface="Arial"/>
               </a:rPr>
@@ -12886,7 +12886,7 @@
             <a:r>
               <a:rPr sz="1200" b="1">
                 <a:solidFill>
-                  <a:srgbClr val="EBF0F6"/>
+                  <a:srgbClr val="263238"/>
                 </a:solidFill>
                 <a:latin typeface="Arial"/>
               </a:rPr>
@@ -12925,7 +12925,7 @@
             <a:r>
               <a:rPr sz="1000" b="0">
                 <a:solidFill>
-                  <a:srgbClr val="ABB9C7"/>
+                  <a:srgbClr val="64748B"/>
                 </a:solidFill>
                 <a:latin typeface="Arial"/>
               </a:rPr>
@@ -12964,7 +12964,7 @@
             <a:r>
               <a:rPr sz="2400" b="0">
                 <a:solidFill>
-                  <a:srgbClr val="ABB9C7"/>
+                  <a:srgbClr val="64748B"/>
                 </a:solidFill>
                 <a:latin typeface="Arial"/>
               </a:rPr>
@@ -12988,7 +12988,7 @@
             <a:avLst/>
           </a:prstGeom>
           <a:solidFill>
-            <a:srgbClr val="1C2A3D"/>
+            <a:srgbClr val="F1F5F9"/>
           </a:solidFill>
           <a:ln>
             <a:noFill/>
@@ -13046,7 +13046,7 @@
             <a:r>
               <a:rPr sz="2500" b="1">
                 <a:solidFill>
-                  <a:srgbClr val="4AB8A7"/>
+                  <a:srgbClr val="2E6F9E"/>
                 </a:solidFill>
                 <a:latin typeface="Arial"/>
               </a:rPr>
@@ -13085,7 +13085,7 @@
             <a:r>
               <a:rPr sz="1200" b="1">
                 <a:solidFill>
-                  <a:srgbClr val="EBF0F6"/>
+                  <a:srgbClr val="263238"/>
                 </a:solidFill>
                 <a:latin typeface="Arial"/>
               </a:rPr>
@@ -13124,7 +13124,7 @@
             <a:r>
               <a:rPr sz="1000" b="0">
                 <a:solidFill>
-                  <a:srgbClr val="ABB9C7"/>
+                  <a:srgbClr val="64748B"/>
                 </a:solidFill>
                 <a:latin typeface="Arial"/>
               </a:rPr>
@@ -13163,7 +13163,7 @@
             <a:r>
               <a:rPr sz="2400" b="0">
                 <a:solidFill>
-                  <a:srgbClr val="ABB9C7"/>
+                  <a:srgbClr val="64748B"/>
                 </a:solidFill>
                 <a:latin typeface="Arial"/>
               </a:rPr>
@@ -13187,7 +13187,7 @@
             <a:avLst/>
           </a:prstGeom>
           <a:solidFill>
-            <a:srgbClr val="1C2A3D"/>
+            <a:srgbClr val="F1F5F9"/>
           </a:solidFill>
           <a:ln>
             <a:noFill/>
@@ -13245,7 +13245,7 @@
             <a:r>
               <a:rPr sz="2500" b="1">
                 <a:solidFill>
-                  <a:srgbClr val="E8874B"/>
+                  <a:srgbClr val="A8B4C0"/>
                 </a:solidFill>
                 <a:latin typeface="Arial"/>
               </a:rPr>
@@ -13284,7 +13284,7 @@
             <a:r>
               <a:rPr sz="1200" b="1">
                 <a:solidFill>
-                  <a:srgbClr val="EBF0F6"/>
+                  <a:srgbClr val="263238"/>
                 </a:solidFill>
                 <a:latin typeface="Arial"/>
               </a:rPr>
@@ -13323,7 +13323,7 @@
             <a:r>
               <a:rPr sz="1000" b="0">
                 <a:solidFill>
-                  <a:srgbClr val="ABB9C7"/>
+                  <a:srgbClr val="64748B"/>
                 </a:solidFill>
                 <a:latin typeface="Arial"/>
               </a:rPr>
@@ -13362,7 +13362,7 @@
             <a:r>
               <a:rPr sz="1700" b="1">
                 <a:solidFill>
-                  <a:srgbClr val="EBF0F6"/>
+                  <a:srgbClr val="263238"/>
                 </a:solidFill>
                 <a:latin typeface="Arial"/>
               </a:rPr>
@@ -13401,7 +13401,7 @@
             <a:r>
               <a:rPr sz="1400" b="0">
                 <a:solidFill>
-                  <a:srgbClr val="ABB9C7"/>
+                  <a:srgbClr val="64748B"/>
                 </a:solidFill>
                 <a:latin typeface="Arial"/>
               </a:rPr>
@@ -13443,7 +13443,7 @@
             <a:avLst/>
           </a:prstGeom>
           <a:solidFill>
-            <a:srgbClr val="121B2A"/>
+            <a:srgbClr val="FFFFFF"/>
           </a:solidFill>
           <a:ln>
             <a:noFill/>
@@ -13501,7 +13501,7 @@
             <a:r>
               <a:rPr sz="1000" b="1">
                 <a:solidFill>
-                  <a:srgbClr val="4AB8A7"/>
+                  <a:srgbClr val="2E6F9E"/>
                 </a:solidFill>
                 <a:latin typeface="Arial"/>
               </a:rPr>
@@ -13540,7 +13540,7 @@
             <a:r>
               <a:rPr sz="2600" b="1">
                 <a:solidFill>
-                  <a:srgbClr val="EBF0F6"/>
+                  <a:srgbClr val="263238"/>
                 </a:solidFill>
                 <a:latin typeface="Arial"/>
               </a:rPr>
@@ -13564,7 +13564,7 @@
             <a:avLst/>
           </a:prstGeom>
           <a:solidFill>
-            <a:srgbClr val="1C2A3D"/>
+            <a:srgbClr val="F1F5F9"/>
           </a:solidFill>
           <a:ln>
             <a:noFill/>
@@ -13622,7 +13622,7 @@
             <a:r>
               <a:rPr sz="900" b="0">
                 <a:solidFill>
-                  <a:srgbClr val="ABB9C7"/>
+                  <a:srgbClr val="64748B"/>
                 </a:solidFill>
                 <a:latin typeface="Arial"/>
               </a:rPr>
@@ -13661,7 +13661,7 @@
             <a:r>
               <a:rPr sz="1000" b="0">
                 <a:solidFill>
-                  <a:srgbClr val="ABB9C7"/>
+                  <a:srgbClr val="64748B"/>
                 </a:solidFill>
                 <a:latin typeface="Arial"/>
               </a:rPr>
@@ -13685,7 +13685,7 @@
             <a:avLst/>
           </a:prstGeom>
           <a:solidFill>
-            <a:srgbClr val="1C2A3D"/>
+            <a:srgbClr val="F1F5F9"/>
           </a:solidFill>
           <a:ln>
             <a:noFill/>
@@ -13743,7 +13743,7 @@
             <a:r>
               <a:rPr sz="2500" b="1">
                 <a:solidFill>
-                  <a:srgbClr val="4AB8A7"/>
+                  <a:srgbClr val="2E6F9E"/>
                 </a:solidFill>
                 <a:latin typeface="Arial"/>
               </a:rPr>
@@ -13782,7 +13782,7 @@
             <a:r>
               <a:rPr sz="1200" b="1">
                 <a:solidFill>
-                  <a:srgbClr val="EBF0F6"/>
+                  <a:srgbClr val="263238"/>
                 </a:solidFill>
                 <a:latin typeface="Arial"/>
               </a:rPr>
@@ -13806,7 +13806,7 @@
             <a:avLst/>
           </a:prstGeom>
           <a:solidFill>
-            <a:srgbClr val="1C2A3D"/>
+            <a:srgbClr val="F1F5F9"/>
           </a:solidFill>
           <a:ln>
             <a:noFill/>
@@ -13864,7 +13864,7 @@
             <a:r>
               <a:rPr sz="2500" b="1">
                 <a:solidFill>
-                  <a:srgbClr val="5A89B2"/>
+                  <a:srgbClr val="2E6F9E"/>
                 </a:solidFill>
                 <a:latin typeface="Arial"/>
               </a:rPr>
@@ -13903,7 +13903,7 @@
             <a:r>
               <a:rPr sz="1200" b="1">
                 <a:solidFill>
-                  <a:srgbClr val="EBF0F6"/>
+                  <a:srgbClr val="263238"/>
                 </a:solidFill>
                 <a:latin typeface="Arial"/>
               </a:rPr>
@@ -13927,7 +13927,7 @@
             <a:avLst/>
           </a:prstGeom>
           <a:solidFill>
-            <a:srgbClr val="1C2A3D"/>
+            <a:srgbClr val="F1F5F9"/>
           </a:solidFill>
           <a:ln>
             <a:noFill/>
@@ -13985,7 +13985,7 @@
             <a:r>
               <a:rPr sz="2500" b="1">
                 <a:solidFill>
-                  <a:srgbClr val="E8874B"/>
+                  <a:srgbClr val="A8B4C0"/>
                 </a:solidFill>
                 <a:latin typeface="Arial"/>
               </a:rPr>
@@ -14024,7 +14024,7 @@
             <a:r>
               <a:rPr sz="1200" b="1">
                 <a:solidFill>
-                  <a:srgbClr val="EBF0F6"/>
+                  <a:srgbClr val="263238"/>
                 </a:solidFill>
                 <a:latin typeface="Arial"/>
               </a:rPr>
@@ -14048,7 +14048,7 @@
             <a:avLst/>
           </a:prstGeom>
           <a:solidFill>
-            <a:srgbClr val="E8874B"/>
+            <a:srgbClr val="A8B4C0"/>
           </a:solidFill>
           <a:ln>
             <a:noFill/>
@@ -14106,7 +14106,7 @@
             <a:r>
               <a:rPr sz="1400" b="0">
                 <a:solidFill>
-                  <a:srgbClr val="EBF0F6"/>
+                  <a:srgbClr val="263238"/>
                 </a:solidFill>
                 <a:latin typeface="Arial"/>
               </a:rPr>
@@ -14130,7 +14130,7 @@
             <a:avLst/>
           </a:prstGeom>
           <a:solidFill>
-            <a:srgbClr val="4AB8A7"/>
+            <a:srgbClr val="2E6F9E"/>
           </a:solidFill>
           <a:ln>
             <a:noFill/>
@@ -14188,7 +14188,7 @@
             <a:r>
               <a:rPr sz="1400" b="0">
                 <a:solidFill>
-                  <a:srgbClr val="EBF0F6"/>
+                  <a:srgbClr val="263238"/>
                 </a:solidFill>
                 <a:latin typeface="Arial"/>
               </a:rPr>
@@ -14212,7 +14212,7 @@
             <a:avLst/>
           </a:prstGeom>
           <a:solidFill>
-            <a:srgbClr val="4AB8A7"/>
+            <a:srgbClr val="2E6F9E"/>
           </a:solidFill>
           <a:ln>
             <a:noFill/>
@@ -14270,7 +14270,7 @@
             <a:r>
               <a:rPr sz="1400" b="0">
                 <a:solidFill>
-                  <a:srgbClr val="EBF0F6"/>
+                  <a:srgbClr val="263238"/>
                 </a:solidFill>
                 <a:latin typeface="Arial"/>
               </a:rPr>
@@ -14294,7 +14294,7 @@
             <a:avLst/>
           </a:prstGeom>
           <a:solidFill>
-            <a:srgbClr val="4AB8A7"/>
+            <a:srgbClr val="2E6F9E"/>
           </a:solidFill>
           <a:ln>
             <a:noFill/>
@@ -14352,7 +14352,7 @@
             <a:r>
               <a:rPr sz="1400" b="0">
                 <a:solidFill>
-                  <a:srgbClr val="EBF0F6"/>
+                  <a:srgbClr val="263238"/>
                 </a:solidFill>
                 <a:latin typeface="Arial"/>
               </a:rPr>
@@ -14394,7 +14394,7 @@
             <a:avLst/>
           </a:prstGeom>
           <a:solidFill>
-            <a:srgbClr val="121B2A"/>
+            <a:srgbClr val="FFFFFF"/>
           </a:solidFill>
           <a:ln>
             <a:noFill/>
@@ -14452,7 +14452,7 @@
             <a:r>
               <a:rPr sz="1000" b="1">
                 <a:solidFill>
-                  <a:srgbClr val="4AB8A7"/>
+                  <a:srgbClr val="2E6F9E"/>
                 </a:solidFill>
                 <a:latin typeface="Arial"/>
               </a:rPr>
@@ -14491,7 +14491,7 @@
             <a:r>
               <a:rPr sz="2600" b="1">
                 <a:solidFill>
-                  <a:srgbClr val="EBF0F6"/>
+                  <a:srgbClr val="263238"/>
                 </a:solidFill>
                 <a:latin typeface="Arial"/>
               </a:rPr>
@@ -14515,7 +14515,7 @@
             <a:avLst/>
           </a:prstGeom>
           <a:solidFill>
-            <a:srgbClr val="1C2A3D"/>
+            <a:srgbClr val="F1F5F9"/>
           </a:solidFill>
           <a:ln>
             <a:noFill/>
@@ -14573,7 +14573,7 @@
             <a:r>
               <a:rPr sz="900" b="0">
                 <a:solidFill>
-                  <a:srgbClr val="ABB9C7"/>
+                  <a:srgbClr val="64748B"/>
                 </a:solidFill>
                 <a:latin typeface="Arial"/>
               </a:rPr>
@@ -14612,7 +14612,7 @@
             <a:r>
               <a:rPr sz="1000" b="0">
                 <a:solidFill>
-                  <a:srgbClr val="ABB9C7"/>
+                  <a:srgbClr val="64748B"/>
                 </a:solidFill>
                 <a:latin typeface="Arial"/>
               </a:rPr>
@@ -14675,7 +14675,7 @@
             <a:r>
               <a:rPr sz="1100" b="0">
                 <a:solidFill>
-                  <a:srgbClr val="ABB9C7"/>
+                  <a:srgbClr val="64748B"/>
                 </a:solidFill>
                 <a:latin typeface="Arial"/>
               </a:rPr>
@@ -14717,7 +14717,7 @@
             <a:avLst/>
           </a:prstGeom>
           <a:solidFill>
-            <a:srgbClr val="121B2A"/>
+            <a:srgbClr val="FFFFFF"/>
           </a:solidFill>
           <a:ln>
             <a:noFill/>
@@ -14775,7 +14775,7 @@
             <a:r>
               <a:rPr sz="1000" b="1">
                 <a:solidFill>
-                  <a:srgbClr val="4AB8A7"/>
+                  <a:srgbClr val="2E6F9E"/>
                 </a:solidFill>
                 <a:latin typeface="Arial"/>
               </a:rPr>
@@ -14814,7 +14814,7 @@
             <a:r>
               <a:rPr sz="2600" b="1">
                 <a:solidFill>
-                  <a:srgbClr val="EBF0F6"/>
+                  <a:srgbClr val="263238"/>
                 </a:solidFill>
                 <a:latin typeface="Arial"/>
               </a:rPr>
@@ -14838,7 +14838,7 @@
             <a:avLst/>
           </a:prstGeom>
           <a:solidFill>
-            <a:srgbClr val="1C2A3D"/>
+            <a:srgbClr val="F1F5F9"/>
           </a:solidFill>
           <a:ln>
             <a:noFill/>
@@ -14896,7 +14896,7 @@
             <a:r>
               <a:rPr sz="900" b="0">
                 <a:solidFill>
-                  <a:srgbClr val="ABB9C7"/>
+                  <a:srgbClr val="64748B"/>
                 </a:solidFill>
                 <a:latin typeface="Arial"/>
               </a:rPr>
@@ -14935,7 +14935,7 @@
             <a:r>
               <a:rPr sz="1000" b="0">
                 <a:solidFill>
-                  <a:srgbClr val="ABB9C7"/>
+                  <a:srgbClr val="64748B"/>
                 </a:solidFill>
                 <a:latin typeface="Arial"/>
               </a:rPr>
@@ -14998,7 +14998,7 @@
             <a:r>
               <a:rPr sz="1100" b="0">
                 <a:solidFill>
-                  <a:srgbClr val="ABB9C7"/>
+                  <a:srgbClr val="64748B"/>
                 </a:solidFill>
                 <a:latin typeface="Arial"/>
               </a:rPr>
@@ -15040,7 +15040,7 @@
             <a:avLst/>
           </a:prstGeom>
           <a:solidFill>
-            <a:srgbClr val="121B2A"/>
+            <a:srgbClr val="FFFFFF"/>
           </a:solidFill>
           <a:ln>
             <a:noFill/>
@@ -15098,7 +15098,7 @@
             <a:r>
               <a:rPr sz="1000" b="1">
                 <a:solidFill>
-                  <a:srgbClr val="4AB8A7"/>
+                  <a:srgbClr val="2E6F9E"/>
                 </a:solidFill>
                 <a:latin typeface="Arial"/>
               </a:rPr>
@@ -15137,7 +15137,7 @@
             <a:r>
               <a:rPr sz="2600" b="1">
                 <a:solidFill>
-                  <a:srgbClr val="EBF0F6"/>
+                  <a:srgbClr val="263238"/>
                 </a:solidFill>
                 <a:latin typeface="Arial"/>
               </a:rPr>
@@ -15161,7 +15161,7 @@
             <a:avLst/>
           </a:prstGeom>
           <a:solidFill>
-            <a:srgbClr val="1C2A3D"/>
+            <a:srgbClr val="F1F5F9"/>
           </a:solidFill>
           <a:ln>
             <a:noFill/>
@@ -15219,7 +15219,7 @@
             <a:r>
               <a:rPr sz="900" b="0">
                 <a:solidFill>
-                  <a:srgbClr val="ABB9C7"/>
+                  <a:srgbClr val="64748B"/>
                 </a:solidFill>
                 <a:latin typeface="Arial"/>
               </a:rPr>
@@ -15258,7 +15258,7 @@
             <a:r>
               <a:rPr sz="1000" b="0">
                 <a:solidFill>
-                  <a:srgbClr val="ABB9C7"/>
+                  <a:srgbClr val="64748B"/>
                 </a:solidFill>
                 <a:latin typeface="Arial"/>
               </a:rPr>
@@ -15321,7 +15321,7 @@
             <a:r>
               <a:rPr sz="1200" b="0">
                 <a:solidFill>
-                  <a:srgbClr val="ABB9C7"/>
+                  <a:srgbClr val="64748B"/>
                 </a:solidFill>
                 <a:latin typeface="Arial"/>
               </a:rPr>

</xml_diff>

<commit_message>
fix(presentation): deriva las cifras y unifica el formato de las diapositivas
Las diapositivas del PowerPoint fijaban en texto varias cifras (284.807,
1.081, 198.608, 84.976, 142, 0,336, 0,675) que quedaban obsoletas si el
pipeline se reejecutaba con otro protocolo. Ahora se derivan del dataset y
de los CSV mediante DeckFigures, y el espacio de búsqueda se resume desde
PARAMETER_GRIDS, de modo que la diapositiva no puede contradecir al código.

El formato numérico pasa a español en ambos formatos: coma decimal, punto
de miles y porcentaje separado, igual que el Beamer. Se unifican también
los nombres de los integrantes.

La fuente Beamer incorpora el espacio de búsqueda en la diapositiva
principal 7, según la estructura sugerida por el enunciado, y aclara que
en k-NN los pesos por distancia son fijos y no se buscan.

Se añaden cuatro pruebas: formato numérico, resumen de la grilla y una
que fija las cifras mostradas en el deck.
</commit_message>
<xml_diff>
--- a/documentacion/presentacion/defensa_fraude.pptx
+++ b/documentacion/presentacion/defensa_fraude.pptx
@@ -3335,7 +3335,7 @@
                 </a:solidFill>
                 <a:latin typeface="Arial"/>
               </a:rPr>
-              <a:t>Integrantes: Fernando Valdés Gomez · Juan Muñoz Veloso</a:t>
+              <a:t>Integrantes: Fernando Alonso Valdés Gómez · Juan Francisco Muñoz Veloso</a:t>
             </a:r>
           </a:p>
         </p:txBody>
@@ -4345,7 +4345,7 @@
                 </a:solidFill>
                 <a:latin typeface="Arial"/>
               </a:rPr>
-              <a:t>84,923</a:t>
+              <a:t>84.923</a:t>
             </a:r>
           </a:p>
         </p:txBody>
@@ -4765,7 +4765,7 @@
                 </a:solidFill>
                 <a:latin typeface="Arial"/>
               </a:rPr>
-              <a:t>99.833%</a:t>
+              <a:t>99,833 %</a:t>
             </a:r>
           </a:p>
         </p:txBody>
@@ -4925,7 +4925,7 @@
                 </a:solidFill>
                 <a:latin typeface="Arial"/>
               </a:rPr>
-              <a:t>76.2% → 80.4%</a:t>
+              <a:t>76,2 % → 80,4 %</a:t>
             </a:r>
           </a:p>
         </p:txBody>
@@ -5085,7 +5085,7 @@
                 </a:solidFill>
                 <a:latin typeface="Arial"/>
               </a:rPr>
-              <a:t>67.5%</a:t>
+              <a:t>67,5 %</a:t>
             </a:r>
           </a:p>
         </p:txBody>
@@ -5409,7 +5409,7 @@
                 </a:solidFill>
                 <a:latin typeface="Arial"/>
               </a:rPr>
-              <a:t>El bosque con submuestreo detecta algo menos que el árbol compensado, pero eleva la precisión de 0,336 a 0,675.</a:t>
+              <a:t>El bosque con submuestreo detecta 2,7 puntos porcentuales menos que el árbol compensado, pero eleva la precisión de 0,336 a 0,675.</a:t>
             </a:r>
           </a:p>
         </p:txBody>
@@ -5751,7 +5751,7 @@
                 </a:solidFill>
                 <a:latin typeface="Arial"/>
               </a:rPr>
-              <a:t>80.4%</a:t>
+              <a:t>80,4 %</a:t>
             </a:r>
           </a:p>
         </p:txBody>
@@ -5829,7 +5829,7 @@
                 </a:solidFill>
                 <a:latin typeface="Arial"/>
               </a:rPr>
-              <a:t>FNR 19.6% · precisión 67.5%</a:t>
+              <a:t>FNR 19,6 % · precisión 67,5 %</a:t>
             </a:r>
           </a:p>
         </p:txBody>
@@ -6456,7 +6456,7 @@
                 </a:solidFill>
                 <a:latin typeface="Arial"/>
               </a:rPr>
-              <a:t>Cinco pliegues compartidos · sensibilidad y precisión de fraude</a:t>
+              <a:t>5 pliegues compartidos · sensibilidad y precisión de fraude</a:t>
             </a:r>
           </a:p>
         </p:txBody>
@@ -6807,7 +6807,7 @@
                           </a:solidFill>
                           <a:latin typeface="Arial"/>
                         </a:rPr>
-                        <a:t>79.3% ± 8.6%</a:t>
+                        <a:t>79,3 % ± 8,6 %</a:t>
                       </a:r>
                     </a:p>
                   </a:txBody>
@@ -6830,7 +6830,7 @@
                           </a:solidFill>
                           <a:latin typeface="Arial"/>
                         </a:rPr>
-                        <a:t>91.2%</a:t>
+                        <a:t>91,2 %</a:t>
                       </a:r>
                     </a:p>
                   </a:txBody>
@@ -6924,7 +6924,7 @@
                           </a:solidFill>
                           <a:latin typeface="Arial"/>
                         </a:rPr>
-                        <a:t>86.6% ± 6.1%</a:t>
+                        <a:t>86,6 % ± 6,1 %</a:t>
                       </a:r>
                     </a:p>
                   </a:txBody>
@@ -6947,7 +6947,7 @@
                           </a:solidFill>
                           <a:latin typeface="Arial"/>
                         </a:rPr>
-                        <a:t>37.5%</a:t>
+                        <a:t>37,5 %</a:t>
                       </a:r>
                     </a:p>
                   </a:txBody>
@@ -7041,7 +7041,7 @@
                           </a:solidFill>
                           <a:latin typeface="Arial"/>
                         </a:rPr>
-                        <a:t>69.6% ± 18.4%</a:t>
+                        <a:t>69,6 % ± 18,4 %</a:t>
                       </a:r>
                     </a:p>
                   </a:txBody>
@@ -7064,7 +7064,7 @@
                           </a:solidFill>
                           <a:latin typeface="Arial"/>
                         </a:rPr>
-                        <a:t>79.8%</a:t>
+                        <a:t>79,8 %</a:t>
                       </a:r>
                     </a:p>
                   </a:txBody>
@@ -7158,7 +7158,7 @@
                           </a:solidFill>
                           <a:latin typeface="Arial"/>
                         </a:rPr>
-                        <a:t>85.4% ± 6.4%</a:t>
+                        <a:t>85,4 % ± 6,4 %</a:t>
                       </a:r>
                     </a:p>
                   </a:txBody>
@@ -7181,7 +7181,7 @@
                           </a:solidFill>
                           <a:latin typeface="Arial"/>
                         </a:rPr>
-                        <a:t>18.6%</a:t>
+                        <a:t>18,6 %</a:t>
                       </a:r>
                     </a:p>
                   </a:txBody>
@@ -7252,7 +7252,7 @@
                           </a:solidFill>
                           <a:latin typeface="Arial"/>
                         </a:rPr>
-                        <a:t>C=10.0</a:t>
+                        <a:t>C=10</a:t>
                       </a:r>
                     </a:p>
                   </a:txBody>
@@ -7275,7 +7275,7 @@
                           </a:solidFill>
                           <a:latin typeface="Arial"/>
                         </a:rPr>
-                        <a:t>58.7% ± 15.6%</a:t>
+                        <a:t>58,7 % ± 15,6 %</a:t>
                       </a:r>
                     </a:p>
                   </a:txBody>
@@ -7298,7 +7298,7 @@
                           </a:solidFill>
                           <a:latin typeface="Arial"/>
                         </a:rPr>
-                        <a:t>88.5%</a:t>
+                        <a:t>88,5 %</a:t>
                       </a:r>
                     </a:p>
                   </a:txBody>
@@ -7369,7 +7369,7 @@
                           </a:solidFill>
                           <a:latin typeface="Arial"/>
                         </a:rPr>
-                        <a:t>C=10.0</a:t>
+                        <a:t>C=10</a:t>
                       </a:r>
                     </a:p>
                   </a:txBody>
@@ -7392,7 +7392,7 @@
                           </a:solidFill>
                           <a:latin typeface="Arial"/>
                         </a:rPr>
-                        <a:t>86.5% ± 9.3%</a:t>
+                        <a:t>86,5 % ± 9,3 %</a:t>
                       </a:r>
                     </a:p>
                   </a:txBody>
@@ -7415,7 +7415,7 @@
                           </a:solidFill>
                           <a:latin typeface="Arial"/>
                         </a:rPr>
-                        <a:t>21.2%</a:t>
+                        <a:t>21,2 %</a:t>
                       </a:r>
                     </a:p>
                   </a:txBody>
@@ -7509,7 +7509,7 @@
                           </a:solidFill>
                           <a:latin typeface="Arial"/>
                         </a:rPr>
-                        <a:t>74.3% ± 14.7%</a:t>
+                        <a:t>74,3 % ± 14,7 %</a:t>
                       </a:r>
                     </a:p>
                   </a:txBody>
@@ -7532,7 +7532,7 @@
                           </a:solidFill>
                           <a:latin typeface="Arial"/>
                         </a:rPr>
-                        <a:t>91.6%</a:t>
+                        <a:t>91,6 %</a:t>
                       </a:r>
                     </a:p>
                   </a:txBody>
@@ -7626,7 +7626,7 @@
                           </a:solidFill>
                           <a:latin typeface="Arial"/>
                         </a:rPr>
-                        <a:t>87.9% ± 5.5%</a:t>
+                        <a:t>87,9 % ± 5,5 %</a:t>
                       </a:r>
                     </a:p>
                   </a:txBody>
@@ -7649,7 +7649,7 @@
                           </a:solidFill>
                           <a:latin typeface="Arial"/>
                         </a:rPr>
-                        <a:t>45.0%</a:t>
+                        <a:t>45,0 %</a:t>
                       </a:r>
                     </a:p>
                   </a:txBody>
@@ -7698,7 +7698,7 @@
                 </a:solidFill>
                 <a:latin typeface="Arial"/>
               </a:rPr>
-              <a:t>Rangos evaluados: k-NN n_neighbors={3, 5, 7}; árbol max_depth={5, 10, None} y min_samples_leaf={1, 5}; SVM C={0.1, 1, 10}; bosque n_estimators={11, 21} y max_depth={6, 12}. El bosque usa max_features=√p.</a:t>
+              <a:t>Rangos evaluados: k-NN n_neighbors=3, 5, 7; Árbol de decisión max_depth=5, 10, libre; min_samples_leaf=1, 5; SVM lineal C=0,1, 1, 10; Random Forest propio n_estimators=11, 21; max_depth=6, 12. El bosque usa max_features=√p.</a:t>
             </a:r>
           </a:p>
         </p:txBody>
@@ -8276,7 +8276,7 @@
                           </a:solidFill>
                           <a:latin typeface="Arial"/>
                         </a:rPr>
-                        <a:t>74.6% ± 0.0 pp</a:t>
+                        <a:t>74,6 % ± 0,0 pp</a:t>
                       </a:r>
                     </a:p>
                   </a:txBody>
@@ -8299,7 +8299,7 @@
                           </a:solidFill>
                           <a:latin typeface="Arial"/>
                         </a:rPr>
-                        <a:t>99.996% ± 0.000 pp</a:t>
+                        <a:t>99,996 % ± 0,000 pp</a:t>
                       </a:r>
                     </a:p>
                   </a:txBody>
@@ -8322,7 +8322,7 @@
                           </a:solidFill>
                           <a:latin typeface="Arial"/>
                         </a:rPr>
-                        <a:t>97.2% ± 0.0 pp</a:t>
+                        <a:t>97,2 % ± 0,0 pp</a:t>
                       </a:r>
                     </a:p>
                   </a:txBody>
@@ -8345,7 +8345,7 @@
                           </a:solidFill>
                           <a:latin typeface="Arial"/>
                         </a:rPr>
-                        <a:t>84.5% ± 0.0 pp</a:t>
+                        <a:t>84,5 % ± 0,0 pp</a:t>
                       </a:r>
                     </a:p>
                   </a:txBody>
@@ -8368,7 +8368,7 @@
                           </a:solidFill>
                           <a:latin typeface="Arial"/>
                         </a:rPr>
-                        <a:t>99.95% ± 0.00 pp</a:t>
+                        <a:t>99,95 % ± 0,00 pp</a:t>
                       </a:r>
                     </a:p>
                   </a:txBody>
@@ -8391,7 +8391,7 @@
                           </a:solidFill>
                           <a:latin typeface="Arial"/>
                         </a:rPr>
-                        <a:t>25.4% ± 0.0 pp</a:t>
+                        <a:t>25,4 % ± 0,0 pp</a:t>
                       </a:r>
                     </a:p>
                   </a:txBody>
@@ -8462,7 +8462,7 @@
                           </a:solidFill>
                           <a:latin typeface="Arial"/>
                         </a:rPr>
-                        <a:t>83.4% ± 0.6 pp</a:t>
+                        <a:t>83,4 % ± 0,6 pp</a:t>
                       </a:r>
                     </a:p>
                   </a:txBody>
@@ -8485,7 +8485,7 @@
                           </a:solidFill>
                           <a:latin typeface="Arial"/>
                         </a:rPr>
-                        <a:t>99.681% ± 0.056 pp</a:t>
+                        <a:t>99,681 % ± 0,056 pp</a:t>
                       </a:r>
                     </a:p>
                   </a:txBody>
@@ -8508,7 +8508,7 @@
                           </a:solidFill>
                           <a:latin typeface="Arial"/>
                         </a:rPr>
-                        <a:t>30.7% ± 3.7 pp</a:t>
+                        <a:t>30,7 % ± 3,7 pp</a:t>
                       </a:r>
                     </a:p>
                   </a:txBody>
@@ -8531,7 +8531,7 @@
                           </a:solidFill>
                           <a:latin typeface="Arial"/>
                         </a:rPr>
-                        <a:t>44.8% ± 3.9 pp</a:t>
+                        <a:t>44,8 % ± 3,9 pp</a:t>
                       </a:r>
                     </a:p>
                   </a:txBody>
@@ -8554,7 +8554,7 @@
                           </a:solidFill>
                           <a:latin typeface="Arial"/>
                         </a:rPr>
-                        <a:t>99.65% ± 0.06 pp</a:t>
+                        <a:t>99,65 % ± 0,06 pp</a:t>
                       </a:r>
                     </a:p>
                   </a:txBody>
@@ -8577,7 +8577,7 @@
                           </a:solidFill>
                           <a:latin typeface="Arial"/>
                         </a:rPr>
-                        <a:t>16.6% ± 0.6 pp</a:t>
+                        <a:t>16,6 % ± 0,6 pp</a:t>
                       </a:r>
                     </a:p>
                   </a:txBody>
@@ -8648,7 +8648,7 @@
                           </a:solidFill>
                           <a:latin typeface="Arial"/>
                         </a:rPr>
-                        <a:t>63.5% ± 0.3 pp</a:t>
+                        <a:t>63,5 % ± 0,3 pp</a:t>
                       </a:r>
                     </a:p>
                   </a:txBody>
@@ -8671,7 +8671,7 @@
                           </a:solidFill>
                           <a:latin typeface="Arial"/>
                         </a:rPr>
-                        <a:t>99.990% ± 0.002 pp</a:t>
+                        <a:t>99,990 % ± 0,002 pp</a:t>
                       </a:r>
                     </a:p>
                   </a:txBody>
@@ -8694,7 +8694,7 @@
                           </a:solidFill>
                           <a:latin typeface="Arial"/>
                         </a:rPr>
-                        <a:t>91.1% ± 1.2 pp</a:t>
+                        <a:t>91,1 % ± 1,2 pp</a:t>
                       </a:r>
                     </a:p>
                   </a:txBody>
@@ -8717,7 +8717,7 @@
                           </a:solidFill>
                           <a:latin typeface="Arial"/>
                         </a:rPr>
-                        <a:t>74.9% ± 0.4 pp</a:t>
+                        <a:t>74,9 % ± 0,4 pp</a:t>
                       </a:r>
                     </a:p>
                   </a:txBody>
@@ -8740,7 +8740,7 @@
                           </a:solidFill>
                           <a:latin typeface="Arial"/>
                         </a:rPr>
-                        <a:t>99.93% ± 0.00 pp</a:t>
+                        <a:t>99,93 % ± 0,00 pp</a:t>
                       </a:r>
                     </a:p>
                   </a:txBody>
@@ -8763,7 +8763,7 @@
                           </a:solidFill>
                           <a:latin typeface="Arial"/>
                         </a:rPr>
-                        <a:t>36.5% ± 0.3 pp</a:t>
+                        <a:t>36,5 % ± 0,3 pp</a:t>
                       </a:r>
                     </a:p>
                   </a:txBody>
@@ -8834,7 +8834,7 @@
                           </a:solidFill>
                           <a:latin typeface="Arial"/>
                         </a:rPr>
-                        <a:t>83.1% ± 2.7 pp</a:t>
+                        <a:t>83,1 % ± 2,7 pp</a:t>
                       </a:r>
                     </a:p>
                   </a:txBody>
@@ -8857,7 +8857,7 @@
                           </a:solidFill>
                           <a:latin typeface="Arial"/>
                         </a:rPr>
-                        <a:t>99.692% ± 0.138 pp</a:t>
+                        <a:t>99,692 % ± 0,138 pp</a:t>
                       </a:r>
                     </a:p>
                   </a:txBody>
@@ -8880,7 +8880,7 @@
                           </a:solidFill>
                           <a:latin typeface="Arial"/>
                         </a:rPr>
-                        <a:t>33.6% ± 10.1 pp</a:t>
+                        <a:t>33,6 % ± 10,1 pp</a:t>
                       </a:r>
                     </a:p>
                   </a:txBody>
@@ -8903,7 +8903,7 @@
                           </a:solidFill>
                           <a:latin typeface="Arial"/>
                         </a:rPr>
-                        <a:t>47.0% ± 9.6 pp</a:t>
+                        <a:t>47,0 % ± 9,6 pp</a:t>
                       </a:r>
                     </a:p>
                   </a:txBody>
@@ -8926,7 +8926,7 @@
                           </a:solidFill>
                           <a:latin typeface="Arial"/>
                         </a:rPr>
-                        <a:t>99.66% ± 0.13 pp</a:t>
+                        <a:t>99,66 % ± 0,13 pp</a:t>
                       </a:r>
                     </a:p>
                   </a:txBody>
@@ -8949,7 +8949,7 @@
                           </a:solidFill>
                           <a:latin typeface="Arial"/>
                         </a:rPr>
-                        <a:t>16.9% ± 2.7 pp</a:t>
+                        <a:t>16,9 % ± 2,7 pp</a:t>
                       </a:r>
                     </a:p>
                   </a:txBody>
@@ -9020,7 +9020,7 @@
                           </a:solidFill>
                           <a:latin typeface="Arial"/>
                         </a:rPr>
-                        <a:t>52.1% ± 0.0 pp</a:t>
+                        <a:t>52,1 % ± 0,0 pp</a:t>
                       </a:r>
                     </a:p>
                   </a:txBody>
@@ -9043,7 +9043,7 @@
                           </a:solidFill>
                           <a:latin typeface="Arial"/>
                         </a:rPr>
-                        <a:t>99.987% ± 0.000 pp</a:t>
+                        <a:t>99,987 % ± 0,000 pp</a:t>
                       </a:r>
                     </a:p>
                   </a:txBody>
@@ -9066,7 +9066,7 @@
                           </a:solidFill>
                           <a:latin typeface="Arial"/>
                         </a:rPr>
-                        <a:t>87.1% ± 0.0 pp</a:t>
+                        <a:t>87,1 % ± 0,0 pp</a:t>
                       </a:r>
                     </a:p>
                   </a:txBody>
@@ -9089,7 +9089,7 @@
                           </a:solidFill>
                           <a:latin typeface="Arial"/>
                         </a:rPr>
-                        <a:t>65.2% ± 0.0 pp</a:t>
+                        <a:t>65,2 % ± 0,0 pp</a:t>
                       </a:r>
                     </a:p>
                   </a:txBody>
@@ -9112,7 +9112,7 @@
                           </a:solidFill>
                           <a:latin typeface="Arial"/>
                         </a:rPr>
-                        <a:t>99.91% ± 0.00 pp</a:t>
+                        <a:t>99,91 % ± 0,00 pp</a:t>
                       </a:r>
                     </a:p>
                   </a:txBody>
@@ -9135,7 +9135,7 @@
                           </a:solidFill>
                           <a:latin typeface="Arial"/>
                         </a:rPr>
-                        <a:t>47.9% ± 0.0 pp</a:t>
+                        <a:t>47,9 % ± 0,0 pp</a:t>
                       </a:r>
                     </a:p>
                   </a:txBody>
@@ -9206,7 +9206,7 @@
                           </a:solidFill>
                           <a:latin typeface="Arial"/>
                         </a:rPr>
-                        <a:t>81.0% ± 0.0 pp</a:t>
+                        <a:t>81,0 % ± 0,0 pp</a:t>
                       </a:r>
                     </a:p>
                   </a:txBody>
@@ -9229,7 +9229,7 @@
                           </a:solidFill>
                           <a:latin typeface="Arial"/>
                         </a:rPr>
-                        <a:t>99.885% ± 0.036 pp</a:t>
+                        <a:t>99,885 % ± 0,036 pp</a:t>
                       </a:r>
                     </a:p>
                   </a:txBody>
@@ -9252,7 +9252,7 @@
                           </a:solidFill>
                           <a:latin typeface="Arial"/>
                         </a:rPr>
-                        <a:t>54.8% ± 7.4 pp</a:t>
+                        <a:t>54,8 % ± 7,4 pp</a:t>
                       </a:r>
                     </a:p>
                   </a:txBody>
@@ -9275,7 +9275,7 @@
                           </a:solidFill>
                           <a:latin typeface="Arial"/>
                         </a:rPr>
-                        <a:t>65.2% ± 5.4 pp</a:t>
+                        <a:t>65,2 % ± 5,4 pp</a:t>
                       </a:r>
                     </a:p>
                   </a:txBody>
@@ -9298,7 +9298,7 @@
                           </a:solidFill>
                           <a:latin typeface="Arial"/>
                         </a:rPr>
-                        <a:t>99.85% ± 0.04 pp</a:t>
+                        <a:t>99,85 % ± 0,04 pp</a:t>
                       </a:r>
                     </a:p>
                   </a:txBody>
@@ -9321,7 +9321,7 @@
                           </a:solidFill>
                           <a:latin typeface="Arial"/>
                         </a:rPr>
-                        <a:t>19.0% ± 0.0 pp</a:t>
+                        <a:t>19,0 % ± 0,0 pp</a:t>
                       </a:r>
                     </a:p>
                   </a:txBody>
@@ -9392,7 +9392,7 @@
                           </a:solidFill>
                           <a:latin typeface="Arial"/>
                         </a:rPr>
-                        <a:t>76.2% ± 1.2 pp</a:t>
+                        <a:t>76,2 % ± 1,2 pp</a:t>
                       </a:r>
                     </a:p>
                   </a:txBody>
@@ -9415,7 +9415,7 @@
                           </a:solidFill>
                           <a:latin typeface="Arial"/>
                         </a:rPr>
-                        <a:t>99.993% ± 0.002 pp</a:t>
+                        <a:t>99,993 % ± 0,002 pp</a:t>
                       </a:r>
                     </a:p>
                   </a:txBody>
@@ -9438,7 +9438,7 @@
                           </a:solidFill>
                           <a:latin typeface="Arial"/>
                         </a:rPr>
-                        <a:t>94.6% ± 1.0 pp</a:t>
+                        <a:t>94,6 % ± 1,0 pp</a:t>
                       </a:r>
                     </a:p>
                   </a:txBody>
@@ -9461,7 +9461,7 @@
                           </a:solidFill>
                           <a:latin typeface="Arial"/>
                         </a:rPr>
-                        <a:t>84.4% ± 0.6 pp</a:t>
+                        <a:t>84,4 % ± 0,6 pp</a:t>
                       </a:r>
                     </a:p>
                   </a:txBody>
@@ -9484,7 +9484,7 @@
                           </a:solidFill>
                           <a:latin typeface="Arial"/>
                         </a:rPr>
-                        <a:t>99.95% ± 0.00 pp</a:t>
+                        <a:t>99,95 % ± 0,00 pp</a:t>
                       </a:r>
                     </a:p>
                   </a:txBody>
@@ -9507,7 +9507,7 @@
                           </a:solidFill>
                           <a:latin typeface="Arial"/>
                         </a:rPr>
-                        <a:t>23.8% ± 1.2 pp</a:t>
+                        <a:t>23,8 % ± 1,2 pp</a:t>
                       </a:r>
                     </a:p>
                   </a:txBody>
@@ -9578,7 +9578,7 @@
                           </a:solidFill>
                           <a:latin typeface="Arial"/>
                         </a:rPr>
-                        <a:t>80.4% ± 0.3 pp</a:t>
+                        <a:t>80,4 % ± 0,3 pp</a:t>
                       </a:r>
                     </a:p>
                   </a:txBody>
@@ -9601,7 +9601,7 @@
                           </a:solidFill>
                           <a:latin typeface="Arial"/>
                         </a:rPr>
-                        <a:t>99.935% ± 0.014 pp</a:t>
+                        <a:t>99,935 % ± 0,014 pp</a:t>
                       </a:r>
                     </a:p>
                   </a:txBody>
@@ -9624,7 +9624,7 @@
                           </a:solidFill>
                           <a:latin typeface="Arial"/>
                         </a:rPr>
-                        <a:t>67.5% ± 4.6 pp</a:t>
+                        <a:t>67,5 % ± 4,6 pp</a:t>
                       </a:r>
                     </a:p>
                   </a:txBody>
@@ -9647,7 +9647,7 @@
                           </a:solidFill>
                           <a:latin typeface="Arial"/>
                         </a:rPr>
-                        <a:t>73.3% ± 2.8 pp</a:t>
+                        <a:t>73,3 % ± 2,8 pp</a:t>
                       </a:r>
                     </a:p>
                   </a:txBody>
@@ -9670,7 +9670,7 @@
                           </a:solidFill>
                           <a:latin typeface="Arial"/>
                         </a:rPr>
-                        <a:t>99.90% ± 0.01 pp</a:t>
+                        <a:t>99,90 % ± 0,01 pp</a:t>
                       </a:r>
                     </a:p>
                   </a:txBody>
@@ -9693,7 +9693,7 @@
                           </a:solidFill>
                           <a:latin typeface="Arial"/>
                         </a:rPr>
-                        <a:t>19.6% ± 0.3 pp</a:t>
+                        <a:t>19,6 % ± 0,3 pp</a:t>
                       </a:r>
                     </a:p>
                   </a:txBody>
@@ -11336,7 +11336,7 @@
                 </a:solidFill>
                 <a:latin typeface="Arial"/>
               </a:rPr>
-              <a:t>Cinco pliegues estratificados y compartidos para comparar los modelos.</a:t>
+              <a:t>5 pliegues estratificados y compartidos para comparar los modelos.</a:t>
             </a:r>
           </a:p>
         </p:txBody>
@@ -14274,7 +14274,7 @@
                 </a:solidFill>
                 <a:latin typeface="Arial"/>
               </a:rPr>
-              <a:t>Elegida: Random Forest propio con submuestreo 1:10, sensibilidad 87.9% ± 5.5% y precisión 45.0% en CV.</a:t>
+              <a:t>Elegida: Random Forest propio con submuestreo 1:10, sensibilidad 87,9 % ± 5,5 % y precisión 45,0 % en CV.</a:t>
             </a:r>
           </a:p>
         </p:txBody>

</xml_diff>